<commit_message>
feat(helpdesk): add chat UX, llm-ready flow, docs, and updated slides
</commit_message>
<xml_diff>
--- a/dist/napcore-helpdesk-presentation.pptx
+++ b/dist/napcore-helpdesk-presentation.pptx
@@ -21,6 +21,10 @@
     <p:sldId id="269" r:id="rId15"/>
     <p:sldId id="270" r:id="rId16"/>
     <p:sldId id="271" r:id="rId17"/>
+    <p:sldId id="272" r:id="rId18"/>
+    <p:sldId id="273" r:id="rId19"/>
+    <p:sldId id="274" r:id="rId20"/>
+    <p:sldId id="275" r:id="rId21"/>
   </p:sldIdLst>
   <p:sldSz cx="9144000" cy="5143500" type="screen16x9"/>
   <p:notesSz cx="6858000" cy="9144000"/>
@@ -3130,7 +3134,7 @@
             </a:pPr>
             <a:r>
               <a:rPr/>
-              <a:t>NAPCORE Helpdesk: Trusted FAQ + RAG Architecture</a:t>
+              <a:t>NAPCORE Helpdesk: From Search To Grounded Chat Helpdesk</a:t>
             </a:r>
           </a:p>
         </p:txBody>
@@ -3238,7 +3242,7 @@
             </a:pPr>
             <a:r>
               <a:rPr/>
-              <a:t>User Experience Flow</a:t>
+              <a:t>Data Model Logic</a:t>
             </a:r>
           </a:p>
         </p:txBody>
@@ -3261,35 +3265,28 @@
             <a:pPr lvl="0"/>
             <a:r>
               <a:rPr/>
-              <a:t>User submits question in GUI.</a:t>
-            </a:r>
-          </a:p>
-          <a:p>
-            <a:pPr lvl="0"/>
-            <a:r>
-              <a:rPr/>
-              <a:t>System attempts FAQ match first.</a:t>
-            </a:r>
-          </a:p>
-          <a:p>
-            <a:pPr lvl="0"/>
-            <a:r>
-              <a:rPr/>
-              <a:t>On miss or low confidence, system executes RAG retrieval plus generation.</a:t>
-            </a:r>
-          </a:p>
-          <a:p>
-            <a:pPr lvl="0"/>
-            <a:r>
-              <a:rPr/>
-              <a:t>Response includes references and confidence signal.</a:t>
-            </a:r>
-          </a:p>
-          <a:p>
-            <a:pPr lvl="0"/>
-            <a:r>
-              <a:rPr/>
-              <a:t>Feedback is captured for continuous improvement.</a:t>
+              <a:t>Source governance: approved_repositories -&gt; source_documents -&gt; source_chunks.</a:t>
+            </a:r>
+          </a:p>
+          <a:p>
+            <a:pPr lvl="0"/>
+            <a:r>
+              <a:rPr/>
+              <a:t>FAQ lifecycle: faq_entries -&gt; faq_versions -&gt; review_events.</a:t>
+            </a:r>
+          </a:p>
+          <a:p>
+            <a:pPr lvl="0"/>
+            <a:r>
+              <a:rPr/>
+              <a:t>Runtime telemetry: question_events -&gt; retrieval_events.</a:t>
+            </a:r>
+          </a:p>
+          <a:p>
+            <a:pPr lvl="0"/>
+            <a:r>
+              <a:rPr/>
+              <a:t>Evidence mapping: answer_evidence_links ties answers to source chunks.</a:t>
             </a:r>
           </a:p>
         </p:txBody>
@@ -3336,7 +3333,7 @@
             </a:pPr>
             <a:r>
               <a:rPr/>
-              <a:t>Operations And Governance</a:t>
+              <a:t>Why Hallucinations Are Prevented</a:t>
             </a:r>
           </a:p>
         </p:txBody>
@@ -3359,35 +3356,28 @@
             <a:pPr lvl="0"/>
             <a:r>
               <a:rPr/>
-              <a:t>Reviewer decisions are logged and auditable.</a:t>
-            </a:r>
-          </a:p>
-          <a:p>
-            <a:pPr lvl="0"/>
-            <a:r>
-              <a:rPr/>
-              <a:t>Editorial operations run through Django Admin.</a:t>
-            </a:r>
-          </a:p>
-          <a:p>
-            <a:pPr lvl="0"/>
-            <a:r>
-              <a:rPr/>
-              <a:t>Recurring intents are promoted into curated FAQ backlog.</a:t>
-            </a:r>
-          </a:p>
-          <a:p>
-            <a:pPr lvl="0"/>
-            <a:r>
-              <a:rPr/>
-              <a:t>Re-indexing handles source and standards updates.</a:t>
-            </a:r>
-          </a:p>
-          <a:p>
-            <a:pPr lvl="0"/>
-            <a:r>
-              <a:rPr/>
-              <a:t>Metrics monitor quality and safety continuously.</a:t>
+              <a:t>Only approved repositories are retrievable.</a:t>
+            </a:r>
+          </a:p>
+          <a:p>
+            <a:pPr lvl="0"/>
+            <a:r>
+              <a:rPr/>
+              <a:t>Unsupported claims fail citation and support checks.</a:t>
+            </a:r>
+          </a:p>
+          <a:p>
+            <a:pPr lvl="0"/>
+            <a:r>
+              <a:rPr/>
+              <a:t>Evidence links provide claim-to-source traceability.</a:t>
+            </a:r>
+          </a:p>
+          <a:p>
+            <a:pPr lvl="0"/>
+            <a:r>
+              <a:rPr/>
+              <a:t>Unknown questions produce abstention, not speculation.</a:t>
             </a:r>
           </a:p>
         </p:txBody>
@@ -3434,7 +3424,7 @@
             </a:pPr>
             <a:r>
               <a:rPr/>
-              <a:t>MVP Success Metrics</a:t>
+              <a:t>User Experience Flow</a:t>
             </a:r>
           </a:p>
         </p:txBody>
@@ -3457,28 +3447,42 @@
             <a:pPr lvl="0"/>
             <a:r>
               <a:rPr/>
-              <a:t>Citation coverage for published FAQs: 100%.</a:t>
-            </a:r>
-          </a:p>
-          <a:p>
-            <a:pPr lvl="0"/>
-            <a:r>
-              <a:rPr/>
-              <a:t>Unsupported-claim publication rate: 0%.</a:t>
-            </a:r>
-          </a:p>
-          <a:p>
-            <a:pPr lvl="0"/>
-            <a:r>
-              <a:rPr/>
-              <a:t>P95 latency: &lt;= 8 seconds.</a:t>
-            </a:r>
-          </a:p>
-          <a:p>
-            <a:pPr lvl="0"/>
-            <a:r>
-              <a:rPr/>
-              <a:t>Retrieval success on covered intents: &gt;= 90%.</a:t>
+              <a:t>User opens chat session or operator console and submits question.</a:t>
+            </a:r>
+          </a:p>
+          <a:p>
+            <a:pPr lvl="0"/>
+            <a:r>
+              <a:rPr/>
+              <a:t>System attempts FAQ match first.</a:t>
+            </a:r>
+          </a:p>
+          <a:p>
+            <a:pPr lvl="0"/>
+            <a:r>
+              <a:rPr/>
+              <a:t>On miss or low confidence, the system executes retrieval plus grounded generation.</a:t>
+            </a:r>
+          </a:p>
+          <a:p>
+            <a:pPr lvl="0"/>
+            <a:r>
+              <a:rPr/>
+              <a:t>Response includes references, confidence, and request trace.</a:t>
+            </a:r>
+          </a:p>
+          <a:p>
+            <a:pPr lvl="0"/>
+            <a:r>
+              <a:rPr/>
+              <a:t>Session history supports iterative questioning without losing provenance.</a:t>
+            </a:r>
+          </a:p>
+          <a:p>
+            <a:pPr lvl="0"/>
+            <a:r>
+              <a:rPr/>
+              <a:t>Feedback and editorial routing support continuous improvement.</a:t>
             </a:r>
           </a:p>
         </p:txBody>
@@ -3525,7 +3529,7 @@
             </a:pPr>
             <a:r>
               <a:rPr/>
-              <a:t>Current Artifacts</a:t>
+              <a:t>Current Product State</a:t>
             </a:r>
           </a:p>
         </p:txBody>
@@ -3548,35 +3552,28 @@
             <a:pPr lvl="0"/>
             <a:r>
               <a:rPr/>
-              <a:t>Functional requirements document.</a:t>
-            </a:r>
-          </a:p>
-          <a:p>
-            <a:pPr lvl="0"/>
-            <a:r>
-              <a:rPr/>
-              <a:t>RAG architecture and database logic documents.</a:t>
-            </a:r>
-          </a:p>
-          <a:p>
-            <a:pPr lvl="0"/>
-            <a:r>
-              <a:rPr/>
-              <a:t>Technology baseline: Django 5 + DRF + Django Admin + Celery/Redis.</a:t>
-            </a:r>
-          </a:p>
-          <a:p>
-            <a:pPr lvl="0"/>
-            <a:r>
-              <a:rPr/>
-              <a:t>PlantUML database model and SQL migration.</a:t>
-            </a:r>
-          </a:p>
-          <a:p>
-            <a:pPr lvl="0"/>
-            <a:r>
-              <a:rPr/>
-              <a:t>Diagram render target for reproducible outputs.</a:t>
+              <a:t>Frontend now includes a chat-style session UX alongside the editorial console.</a:t>
+            </a:r>
+          </a:p>
+          <a:p>
+            <a:pPr lvl="0"/>
+            <a:r>
+              <a:rPr/>
+              <a:t>Backend supports deterministic grounded generation and an optional LLM-ready mode.</a:t>
+            </a:r>
+          </a:p>
+          <a:p>
+            <a:pPr lvl="0"/>
+            <a:r>
+              <a:rPr/>
+              <a:t>Knowledge index is built from approved repositories and selected companion repositories.</a:t>
+            </a:r>
+          </a:p>
+          <a:p>
+            <a:pPr lvl="0"/>
+            <a:r>
+              <a:rPr/>
+              <a:t>Editorial board, KPI metrics, and promotion candidate flows remain part of the same product.</a:t>
             </a:r>
           </a:p>
         </p:txBody>
@@ -3613,7 +3610,12 @@
             <p:ph type="title"/>
           </p:nvPr>
         </p:nvSpPr>
-        <p:spPr/>
+        <p:spPr>
+          <a:xfrm>
+            <a:off x="457201" y="204787"/>
+            <a:ext cx="3008313" cy="871538"/>
+          </a:xfrm>
+        </p:spPr>
         <p:txBody>
           <a:bodyPr/>
           <a:lstStyle/>
@@ -3623,63 +3625,71 @@
             </a:pPr>
             <a:r>
               <a:rPr/>
-              <a:t>Next Steps</a:t>
-            </a:r>
-          </a:p>
-        </p:txBody>
-      </p:sp>
-      <p:sp>
-        <p:nvSpPr>
-          <p:cNvPr id="3" name="Content Placeholder 2"/>
-          <p:cNvSpPr>
-            <a:spLocks noGrp="1"/>
-          </p:cNvSpPr>
-          <p:nvPr>
-            <p:ph idx="1"/>
-          </p:nvPr>
-        </p:nvSpPr>
-        <p:spPr/>
-        <p:txBody>
-          <a:bodyPr/>
-          <a:lstStyle/>
-          <a:p>
-            <a:pPr lvl="0" indent="-342900" marL="342900">
-              <a:buAutoNum type="arabicPeriod"/>
-            </a:pPr>
-            <a:r>
-              <a:rPr/>
-              <a:t>Finalize repository allowlist and ingestion profile.</a:t>
-            </a:r>
-          </a:p>
-          <a:p>
-            <a:pPr lvl="0" indent="-342900" marL="342900">
-              <a:buAutoNum type="arabicPeriod"/>
-            </a:pPr>
-            <a:r>
-              <a:rPr/>
-              <a:t>Implement Django/DRF orchestration API for FAQ-first plus RAG fallback.</a:t>
-            </a:r>
-          </a:p>
-          <a:p>
-            <a:pPr lvl="0" indent="-342900" marL="342900">
-              <a:buAutoNum type="arabicPeriod"/>
-            </a:pPr>
-            <a:r>
-              <a:rPr/>
-              <a:t>Configure Django Admin editorial workflow and publication gates.</a:t>
-            </a:r>
-          </a:p>
-          <a:p>
-            <a:pPr lvl="0" indent="-342900" marL="342900">
-              <a:buAutoNum type="arabicPeriod"/>
-            </a:pPr>
-            <a:r>
-              <a:rPr/>
-              <a:t>Run pilot validation against KPI targets.</a:t>
-            </a:r>
-          </a:p>
-        </p:txBody>
-      </p:sp>
+              <a:t>Current Chat UX</a:t>
+            </a:r>
+          </a:p>
+        </p:txBody>
+      </p:sp>
+      <p:sp>
+        <p:nvSpPr>
+          <p:cNvPr id="4" name="Text Placeholder 3"/>
+          <p:cNvSpPr>
+            <a:spLocks noGrp="1"/>
+          </p:cNvSpPr>
+          <p:nvPr>
+            <p:ph idx="2" sz="half" type="body"/>
+          </p:nvPr>
+        </p:nvSpPr>
+        <p:spPr/>
+        <p:txBody>
+          <a:bodyPr/>
+          <a:lstStyle/>
+          <a:p>
+            <a:pPr lvl="0"/>
+            <a:r>
+              <a:rPr/>
+              <a:t>Live chat session view with per-turn evidence, confidence, and request trace.</a:t>
+            </a:r>
+          </a:p>
+          <a:p>
+            <a:pPr lvl="0"/>
+            <a:r>
+              <a:rPr/>
+              <a:t>Same surface supports deterministic grounded answers today and LLM-ready mode later.</a:t>
+            </a:r>
+          </a:p>
+        </p:txBody>
+      </p:sp>
+      <p:pic>
+        <p:nvPicPr>
+          <p:cNvPr descr="docs/presentation/assets/chat-session-ui.png" id="0" name="Picture 1"/>
+          <p:cNvPicPr>
+            <a:picLocks noGrp="1" noChangeAspect="1"/>
+          </p:cNvPicPr>
+          <p:nvPr/>
+        </p:nvPicPr>
+        <p:blipFill>
+          <a:blip r:embed="rId2"/>
+          <a:stretch>
+            <a:fillRect/>
+          </a:stretch>
+        </p:blipFill>
+        <p:spPr bwMode="auto">
+          <a:xfrm>
+            <a:off x="3568700" y="838200"/>
+            <a:ext cx="5105400" cy="3111500"/>
+          </a:xfrm>
+          <a:prstGeom prst="rect">
+            <a:avLst/>
+          </a:prstGeom>
+          <a:noFill/>
+          <a:ln w="9525">
+            <a:noFill/>
+            <a:headEnd/>
+            <a:tailEnd/>
+          </a:ln>
+        </p:spPr>
+      </p:pic>
     </p:spTree>
   </p:cSld>
 </p:sld>
@@ -3722,7 +3732,7 @@
             </a:pPr>
             <a:r>
               <a:rPr/>
-              <a:t>Appendix: Example Questions</a:t>
+              <a:t>Operations And Governance</a:t>
             </a:r>
           </a:p>
         </p:txBody>
@@ -3745,23 +3755,35 @@
             <a:pPr lvl="0"/>
             <a:r>
               <a:rPr/>
-              <a:t>How to use NeTEx for exchanging a timetable?</a:t>
-            </a:r>
-          </a:p>
-          <a:p>
-            <a:pPr lvl="0"/>
-            <a:r>
-              <a:rPr/>
-              <a:t>How to implement IDs for a Stop Place registry?</a:t>
-            </a:r>
-          </a:p>
-          <a:p>
-            <a:pPr lvl="0" indent="0" marL="0">
-              <a:buNone/>
-            </a:pPr>
-            <a:r>
-              <a:rPr/>
-              <a:t>Expected outputs: - practical implementation guidance, - explicit citations, - abstention where evidence is insufficient.</a:t>
+              <a:t>Reviewer decisions are logged and auditable.</a:t>
+            </a:r>
+          </a:p>
+          <a:p>
+            <a:pPr lvl="0"/>
+            <a:r>
+              <a:rPr/>
+              <a:t>Editorial operations run through Django Admin.</a:t>
+            </a:r>
+          </a:p>
+          <a:p>
+            <a:pPr lvl="0"/>
+            <a:r>
+              <a:rPr/>
+              <a:t>Recurring intents are promoted into curated FAQ backlog.</a:t>
+            </a:r>
+          </a:p>
+          <a:p>
+            <a:pPr lvl="0"/>
+            <a:r>
+              <a:rPr/>
+              <a:t>Re-indexing handles source and standards updates.</a:t>
+            </a:r>
+          </a:p>
+          <a:p>
+            <a:pPr lvl="0"/>
+            <a:r>
+              <a:rPr/>
+              <a:t>Metrics monitor quality and safety continuously.</a:t>
             </a:r>
           </a:p>
         </p:txBody>
@@ -3808,7 +3830,7 @@
             </a:pPr>
             <a:r>
               <a:rPr/>
-              <a:t>Notes</a:t>
+              <a:t>MVP Success Metrics</a:t>
             </a:r>
           </a:p>
         </p:txBody>
@@ -3828,12 +3850,314 @@
           <a:bodyPr/>
           <a:lstStyle/>
           <a:p>
+            <a:pPr lvl="0"/>
+            <a:r>
+              <a:rPr/>
+              <a:t>Citation coverage for published FAQs: 100%.</a:t>
+            </a:r>
+          </a:p>
+          <a:p>
+            <a:pPr lvl="0"/>
+            <a:r>
+              <a:rPr/>
+              <a:t>Unsupported-claim publication rate: 0%.</a:t>
+            </a:r>
+          </a:p>
+          <a:p>
+            <a:pPr lvl="0"/>
+            <a:r>
+              <a:rPr/>
+              <a:t>P95 latency: &lt;= 8 seconds.</a:t>
+            </a:r>
+          </a:p>
+          <a:p>
+            <a:pPr lvl="0"/>
+            <a:r>
+              <a:rPr/>
+              <a:t>Retrieval success on covered intents: &gt;= 90%.</a:t>
+            </a:r>
+          </a:p>
+        </p:txBody>
+      </p:sp>
+    </p:spTree>
+  </p:cSld>
+</p:sld>
+</file>
+
+<file path=ppt/slides/slide17.xml><?xml version="1.0" encoding="utf-8"?>
+<p:sld xmlns:a="http://schemas.openxmlformats.org/drawingml/2006/main" xmlns:r="http://schemas.openxmlformats.org/officeDocument/2006/relationships" xmlns:p="http://schemas.openxmlformats.org/presentationml/2006/main">
+  <p:cSld>
+    <p:spTree>
+      <p:nvGrpSpPr>
+        <p:cNvPr id="1" name=""/>
+        <p:cNvGrpSpPr/>
+        <p:nvPr/>
+      </p:nvGrpSpPr>
+      <p:grpSpPr>
+        <a:xfrm>
+          <a:off x="0" y="0"/>
+          <a:ext cx="0" cy="0"/>
+          <a:chOff x="0" y="0"/>
+          <a:chExt cx="0" cy="0"/>
+        </a:xfrm>
+      </p:grpSpPr>
+      <p:sp>
+        <p:nvSpPr>
+          <p:cNvPr id="2" name="Title 1"/>
+          <p:cNvSpPr>
+            <a:spLocks noGrp="1"/>
+          </p:cNvSpPr>
+          <p:nvPr>
+            <p:ph type="title"/>
+          </p:nvPr>
+        </p:nvSpPr>
+        <p:spPr/>
+        <p:txBody>
+          <a:bodyPr/>
+          <a:lstStyle/>
+          <a:p>
             <a:pPr lvl="0" indent="0" marL="0">
               <a:buNone/>
             </a:pPr>
             <a:r>
-              <a:rPr sz="1800"/>
-              <a:t>1. RAG fallback means that when no high-confidence FAQ answer is available, the system retrieves relevant source chunks and then generates an answer grounded in that retrieved evidence.</a:t>
+              <a:rPr/>
+              <a:t>Current Artifacts</a:t>
+            </a:r>
+          </a:p>
+        </p:txBody>
+      </p:sp>
+      <p:sp>
+        <p:nvSpPr>
+          <p:cNvPr id="3" name="Content Placeholder 2"/>
+          <p:cNvSpPr>
+            <a:spLocks noGrp="1"/>
+          </p:cNvSpPr>
+          <p:nvPr>
+            <p:ph idx="1"/>
+          </p:nvPr>
+        </p:nvSpPr>
+        <p:spPr/>
+        <p:txBody>
+          <a:bodyPr/>
+          <a:lstStyle/>
+          <a:p>
+            <a:pPr lvl="0"/>
+            <a:r>
+              <a:rPr/>
+              <a:t>Functional requirements, testing pack, and local run guide.</a:t>
+            </a:r>
+          </a:p>
+          <a:p>
+            <a:pPr lvl="0"/>
+            <a:r>
+              <a:rPr/>
+              <a:t>RAG architecture, database logic, and updated C4 architecture documents.</a:t>
+            </a:r>
+          </a:p>
+          <a:p>
+            <a:pPr lvl="0"/>
+            <a:r>
+              <a:rPr/>
+              <a:t>Technology baseline: Django 5 + DRF backend, React/Vite frontend, editorial workflow.</a:t>
+            </a:r>
+          </a:p>
+          <a:p>
+            <a:pPr lvl="0"/>
+            <a:r>
+              <a:rPr/>
+              <a:t>Chat session UX, deterministic grounded answering, and LLM-ready generation adapter.</a:t>
+            </a:r>
+          </a:p>
+          <a:p>
+            <a:pPr lvl="0"/>
+            <a:r>
+              <a:rPr/>
+              <a:t>PlantUML and exported SVG architecture assets for reproducible documentation.</a:t>
+            </a:r>
+          </a:p>
+        </p:txBody>
+      </p:sp>
+    </p:spTree>
+  </p:cSld>
+</p:sld>
+</file>
+
+<file path=ppt/slides/slide18.xml><?xml version="1.0" encoding="utf-8"?>
+<p:sld xmlns:a="http://schemas.openxmlformats.org/drawingml/2006/main" xmlns:r="http://schemas.openxmlformats.org/officeDocument/2006/relationships" xmlns:p="http://schemas.openxmlformats.org/presentationml/2006/main">
+  <p:cSld>
+    <p:spTree>
+      <p:nvGrpSpPr>
+        <p:cNvPr id="1" name=""/>
+        <p:cNvGrpSpPr/>
+        <p:nvPr/>
+      </p:nvGrpSpPr>
+      <p:grpSpPr>
+        <a:xfrm>
+          <a:off x="0" y="0"/>
+          <a:ext cx="0" cy="0"/>
+          <a:chOff x="0" y="0"/>
+          <a:chExt cx="0" cy="0"/>
+        </a:xfrm>
+      </p:grpSpPr>
+      <p:sp>
+        <p:nvSpPr>
+          <p:cNvPr id="2" name="Title 1"/>
+          <p:cNvSpPr>
+            <a:spLocks noGrp="1"/>
+          </p:cNvSpPr>
+          <p:nvPr>
+            <p:ph type="title"/>
+          </p:nvPr>
+        </p:nvSpPr>
+        <p:spPr/>
+        <p:txBody>
+          <a:bodyPr/>
+          <a:lstStyle/>
+          <a:p>
+            <a:pPr lvl="0" indent="0" marL="0">
+              <a:buNone/>
+            </a:pPr>
+            <a:r>
+              <a:rPr/>
+              <a:t>Next Steps</a:t>
+            </a:r>
+          </a:p>
+        </p:txBody>
+      </p:sp>
+      <p:sp>
+        <p:nvSpPr>
+          <p:cNvPr id="3" name="Content Placeholder 2"/>
+          <p:cNvSpPr>
+            <a:spLocks noGrp="1"/>
+          </p:cNvSpPr>
+          <p:nvPr>
+            <p:ph idx="1"/>
+          </p:nvPr>
+        </p:nvSpPr>
+        <p:spPr/>
+        <p:txBody>
+          <a:bodyPr/>
+          <a:lstStyle/>
+          <a:p>
+            <a:pPr lvl="0" indent="-342900" marL="342900">
+              <a:buAutoNum type="arabicPeriod"/>
+            </a:pPr>
+            <a:r>
+              <a:rPr/>
+              <a:t>Complete pilot testing across chat UX, editorial workflow, and promotion flows.</a:t>
+            </a:r>
+          </a:p>
+          <a:p>
+            <a:pPr lvl="0" indent="-342900" marL="342900">
+              <a:buAutoNum type="arabicPeriod"/>
+            </a:pPr>
+            <a:r>
+              <a:rPr/>
+              <a:t>Enable and evaluate grounded LLM mode against deterministic fallback behavior.</a:t>
+            </a:r>
+          </a:p>
+          <a:p>
+            <a:pPr lvl="0" indent="-342900" marL="342900">
+              <a:buAutoNum type="arabicPeriod"/>
+            </a:pPr>
+            <a:r>
+              <a:rPr/>
+              <a:t>Refine ingestion profiles for companion repositories and standards-specific scopes.</a:t>
+            </a:r>
+          </a:p>
+          <a:p>
+            <a:pPr lvl="0" indent="-342900" marL="342900">
+              <a:buAutoNum type="arabicPeriod"/>
+            </a:pPr>
+            <a:r>
+              <a:rPr/>
+              <a:t>Use pilot evidence to decide production hardening and deployment model.</a:t>
+            </a:r>
+          </a:p>
+        </p:txBody>
+      </p:sp>
+    </p:spTree>
+  </p:cSld>
+</p:sld>
+</file>
+
+<file path=ppt/slides/slide19.xml><?xml version="1.0" encoding="utf-8"?>
+<p:sld xmlns:a="http://schemas.openxmlformats.org/drawingml/2006/main" xmlns:r="http://schemas.openxmlformats.org/officeDocument/2006/relationships" xmlns:p="http://schemas.openxmlformats.org/presentationml/2006/main">
+  <p:cSld>
+    <p:spTree>
+      <p:nvGrpSpPr>
+        <p:cNvPr id="1" name=""/>
+        <p:cNvGrpSpPr/>
+        <p:nvPr/>
+      </p:nvGrpSpPr>
+      <p:grpSpPr>
+        <a:xfrm>
+          <a:off x="0" y="0"/>
+          <a:ext cx="0" cy="0"/>
+          <a:chOff x="0" y="0"/>
+          <a:chExt cx="0" cy="0"/>
+        </a:xfrm>
+      </p:grpSpPr>
+      <p:sp>
+        <p:nvSpPr>
+          <p:cNvPr id="2" name="Title 1"/>
+          <p:cNvSpPr>
+            <a:spLocks noGrp="1"/>
+          </p:cNvSpPr>
+          <p:nvPr>
+            <p:ph type="title"/>
+          </p:nvPr>
+        </p:nvSpPr>
+        <p:spPr/>
+        <p:txBody>
+          <a:bodyPr/>
+          <a:lstStyle/>
+          <a:p>
+            <a:pPr lvl="0" indent="0" marL="0">
+              <a:buNone/>
+            </a:pPr>
+            <a:r>
+              <a:rPr/>
+              <a:t>Appendix: Example Questions</a:t>
+            </a:r>
+          </a:p>
+        </p:txBody>
+      </p:sp>
+      <p:sp>
+        <p:nvSpPr>
+          <p:cNvPr id="3" name="Content Placeholder 2"/>
+          <p:cNvSpPr>
+            <a:spLocks noGrp="1"/>
+          </p:cNvSpPr>
+          <p:nvPr>
+            <p:ph idx="1"/>
+          </p:nvPr>
+        </p:nvSpPr>
+        <p:spPr/>
+        <p:txBody>
+          <a:bodyPr/>
+          <a:lstStyle/>
+          <a:p>
+            <a:pPr lvl="0"/>
+            <a:r>
+              <a:rPr/>
+              <a:t>How to use NeTEx for exchanging a timetable?</a:t>
+            </a:r>
+          </a:p>
+          <a:p>
+            <a:pPr lvl="0"/>
+            <a:r>
+              <a:rPr/>
+              <a:t>How to implement IDs for a Stop Place registry?</a:t>
+            </a:r>
+          </a:p>
+          <a:p>
+            <a:pPr lvl="0" indent="0" marL="0">
+              <a:buNone/>
+            </a:pPr>
+            <a:r>
+              <a:rPr/>
+              <a:t>Expected outputs: - practical implementation guidance, - explicit citations, - abstention where evidence is insufficient.</a:t>
             </a:r>
           </a:p>
         </p:txBody>
@@ -3903,21 +4227,93 @@
             <a:pPr lvl="0"/>
             <a:r>
               <a:rPr/>
-              <a:t>Need a trustworthy helpdesk for multimodal standards implementation.</a:t>
-            </a:r>
-          </a:p>
-          <a:p>
-            <a:pPr lvl="0"/>
-            <a:r>
-              <a:rPr/>
-              <a:t>Main risk is hallucinated or uncited AI guidance.</a:t>
-            </a:r>
-          </a:p>
-          <a:p>
-            <a:pPr lvl="0"/>
-            <a:r>
-              <a:rPr/>
-              <a:t>Goal is grounded answers with traceable references.</a:t>
+              <a:t>Need a trusted answer layer for multimodal standards implementation.</a:t>
+            </a:r>
+          </a:p>
+          <a:p>
+            <a:pPr lvl="0"/>
+            <a:r>
+              <a:rPr/>
+              <a:t>Main risk is fast but uncited guidance that creates delivery risk.</a:t>
+            </a:r>
+          </a:p>
+          <a:p>
+            <a:pPr lvl="0"/>
+            <a:r>
+              <a:rPr/>
+              <a:t>Goal is practical answers with traceable references and controlled escalation.</a:t>
+            </a:r>
+          </a:p>
+        </p:txBody>
+      </p:sp>
+    </p:spTree>
+  </p:cSld>
+</p:sld>
+</file>
+
+<file path=ppt/slides/slide20.xml><?xml version="1.0" encoding="utf-8"?>
+<p:sld xmlns:a="http://schemas.openxmlformats.org/drawingml/2006/main" xmlns:r="http://schemas.openxmlformats.org/officeDocument/2006/relationships" xmlns:p="http://schemas.openxmlformats.org/presentationml/2006/main">
+  <p:cSld>
+    <p:spTree>
+      <p:nvGrpSpPr>
+        <p:cNvPr id="1" name=""/>
+        <p:cNvGrpSpPr/>
+        <p:nvPr/>
+      </p:nvGrpSpPr>
+      <p:grpSpPr>
+        <a:xfrm>
+          <a:off x="0" y="0"/>
+          <a:ext cx="0" cy="0"/>
+          <a:chOff x="0" y="0"/>
+          <a:chExt cx="0" cy="0"/>
+        </a:xfrm>
+      </p:grpSpPr>
+      <p:sp>
+        <p:nvSpPr>
+          <p:cNvPr id="2" name="Title 1"/>
+          <p:cNvSpPr>
+            <a:spLocks noGrp="1"/>
+          </p:cNvSpPr>
+          <p:nvPr>
+            <p:ph type="title"/>
+          </p:nvPr>
+        </p:nvSpPr>
+        <p:spPr/>
+        <p:txBody>
+          <a:bodyPr/>
+          <a:lstStyle/>
+          <a:p>
+            <a:pPr lvl="0" indent="0" marL="0">
+              <a:buNone/>
+            </a:pPr>
+            <a:r>
+              <a:rPr/>
+              <a:t>Notes</a:t>
+            </a:r>
+          </a:p>
+        </p:txBody>
+      </p:sp>
+      <p:sp>
+        <p:nvSpPr>
+          <p:cNvPr id="3" name="Content Placeholder 2"/>
+          <p:cNvSpPr>
+            <a:spLocks noGrp="1"/>
+          </p:cNvSpPr>
+          <p:nvPr>
+            <p:ph idx="1"/>
+          </p:nvPr>
+        </p:nvSpPr>
+        <p:spPr/>
+        <p:txBody>
+          <a:bodyPr/>
+          <a:lstStyle/>
+          <a:p>
+            <a:pPr lvl="0" indent="0" marL="0">
+              <a:buNone/>
+            </a:pPr>
+            <a:r>
+              <a:rPr sz="1800"/>
+              <a:t>1. RAG fallback means that when no high-confidence FAQ answer is available, the system retrieves relevant source chunks and then generates an answer grounded in that retrieved evidence.</a:t>
             </a:r>
           </a:p>
         </p:txBody>
@@ -4221,7 +4617,7 @@
             <a:pPr lvl="0"/>
             <a:r>
               <a:rPr/>
-              <a:t>User channel: GUI-based technical Q and A.</a:t>
+              <a:t>User channel: one operator console with a chat-style helpdesk experience.</a:t>
             </a:r>
           </a:p>
         </p:txBody>
@@ -4268,7 +4664,7 @@
             </a:pPr>
             <a:r>
               <a:rPr/>
-              <a:t>Core Approach</a:t>
+              <a:t>Evolution Of Helpdesk Implementations</a:t>
             </a:r>
           </a:p>
         </p:txBody>
@@ -4291,34 +4687,35 @@
             <a:pPr lvl="0"/>
             <a:r>
               <a:rPr/>
-              <a:t>FAQ-first with RAG fallback.</a:t>
-            </a:r>
-            <a:r>
-              <a:rPr baseline="30000">
-                <a:hlinkClick r:id="rId2" action="ppaction://hlinksldjump"/>
-              </a:rPr>
-              <a:t>1</a:t>
-            </a:r>
-          </a:p>
-          <a:p>
-            <a:pPr lvl="0"/>
-            <a:r>
-              <a:rPr/>
-              <a:t>FAQ-first: return approved canonical answers when confidence is high.</a:t>
-            </a:r>
-          </a:p>
-          <a:p>
-            <a:pPr lvl="0"/>
-            <a:r>
-              <a:rPr/>
-              <a:t>RAG fallback: retrieve source chunks then generate grounded answer.</a:t>
-            </a:r>
-          </a:p>
-          <a:p>
-            <a:pPr lvl="0"/>
-            <a:r>
-              <a:rPr/>
-              <a:t>If evidence is insufficient, abstain explicitly.</a:t>
+              <a:t>Stage 1: keyword search over standards documents.</a:t>
+            </a:r>
+          </a:p>
+          <a:p>
+            <a:pPr lvl="0"/>
+            <a:r>
+              <a:rPr/>
+              <a:t>Stage 2: grounded Q and A with FAQ-first orchestration.</a:t>
+            </a:r>
+          </a:p>
+          <a:p>
+            <a:pPr lvl="0"/>
+            <a:r>
+              <a:rPr/>
+              <a:t>Stage 3: editorial workflow, routing, and KPI visibility.</a:t>
+            </a:r>
+          </a:p>
+          <a:p>
+            <a:pPr lvl="0"/>
+            <a:r>
+              <a:rPr/>
+              <a:t>Stage 4: chat-style sessions ready for deterministic and LLM-backed generation.</a:t>
+            </a:r>
+          </a:p>
+          <a:p>
+            <a:pPr lvl="0"/>
+            <a:r>
+              <a:rPr/>
+              <a:t>The trust model stays fixed: allow-listed repositories, citations, and review gates.</a:t>
             </a:r>
           </a:p>
         </p:txBody>
@@ -4365,7 +4762,7 @@
             </a:pPr>
             <a:r>
               <a:rPr/>
-              <a:t>Trust And Safety</a:t>
+              <a:t>Why The Evolution Matters</a:t>
             </a:r>
           </a:p>
         </p:txBody>
@@ -4388,28 +4785,35 @@
             <a:pPr lvl="0"/>
             <a:r>
               <a:rPr/>
-              <a:t>Repository allowlist enforces knowledge boundary.</a:t>
-            </a:r>
-          </a:p>
-          <a:p>
-            <a:pPr lvl="0"/>
-            <a:r>
-              <a:rPr/>
-              <a:t>Generation limited to retrieved evidence.</a:t>
-            </a:r>
-          </a:p>
-          <a:p>
-            <a:pPr lvl="0"/>
-            <a:r>
-              <a:rPr/>
-              <a:t>Citation gate blocks uncited publication.</a:t>
-            </a:r>
-          </a:p>
-          <a:p>
-            <a:pPr lvl="0"/>
-            <a:r>
-              <a:rPr/>
-              <a:t>Editorial gate enforces draft, review, approve, publish states.</a:t>
+              <a:t>Search helps lookup, but not decision-ready guidance.</a:t>
+            </a:r>
+          </a:p>
+          <a:p>
+            <a:pPr lvl="0"/>
+            <a:r>
+              <a:rPr/>
+              <a:t>FAQ-first gives low-latency canonical answers for recurring issues.</a:t>
+            </a:r>
+          </a:p>
+          <a:p>
+            <a:pPr lvl="0"/>
+            <a:r>
+              <a:rPr/>
+              <a:t>Editorial workflow converts runtime demand into governed knowledge.</a:t>
+            </a:r>
+          </a:p>
+          <a:p>
+            <a:pPr lvl="0"/>
+            <a:r>
+              <a:rPr/>
+              <a:t>Chat sessions improve usability without weakening provenance.</a:t>
+            </a:r>
+          </a:p>
+          <a:p>
+            <a:pPr lvl="0"/>
+            <a:r>
+              <a:rPr/>
+              <a:t>Companion repositories expand coverage without relaxing the trust boundary.</a:t>
             </a:r>
           </a:p>
         </p:txBody>
@@ -4456,7 +4860,7 @@
             </a:pPr>
             <a:r>
               <a:rPr/>
-              <a:t>Functional Requirements Highlights</a:t>
+              <a:t>Core Approach</a:t>
             </a:r>
           </a:p>
         </p:txBody>
@@ -4479,35 +4883,41 @@
             <a:pPr lvl="0"/>
             <a:r>
               <a:rPr/>
-              <a:t>FR-001: developer question answering in GUI.</a:t>
-            </a:r>
-          </a:p>
-          <a:p>
-            <a:pPr lvl="0"/>
-            <a:r>
-              <a:rPr/>
-              <a:t>FR-004: ingestion and indexing of approved GitHub sources.</a:t>
-            </a:r>
-          </a:p>
-          <a:p>
-            <a:pPr lvl="0"/>
-            <a:r>
-              <a:rPr/>
-              <a:t>FR-005: retrieval and grounded generation.</a:t>
-            </a:r>
-          </a:p>
-          <a:p>
-            <a:pPr lvl="0"/>
-            <a:r>
-              <a:rPr/>
-              <a:t>FR-006: anti-hallucination and boundary enforcement.</a:t>
-            </a:r>
-          </a:p>
-          <a:p>
-            <a:pPr lvl="0"/>
-            <a:r>
-              <a:rPr/>
-              <a:t>FR-002 and FR-003: editorial curation and FAQ promotion.</a:t>
+              <a:t>FAQ-first with RAG fallback.</a:t>
+            </a:r>
+            <a:r>
+              <a:rPr baseline="30000">
+                <a:hlinkClick r:id="rId2" action="ppaction://hlinksldjump"/>
+              </a:rPr>
+              <a:t>1</a:t>
+            </a:r>
+          </a:p>
+          <a:p>
+            <a:pPr lvl="0"/>
+            <a:r>
+              <a:rPr/>
+              <a:t>FAQ-first: return approved answers when confidence is high.</a:t>
+            </a:r>
+          </a:p>
+          <a:p>
+            <a:pPr lvl="0"/>
+            <a:r>
+              <a:rPr/>
+              <a:t>RAG fallback: retrieve source chunks, then generate a grounded answer.</a:t>
+            </a:r>
+          </a:p>
+          <a:p>
+            <a:pPr lvl="0"/>
+            <a:r>
+              <a:rPr/>
+              <a:t>Generation profiles: deterministic-grounded now, LLM-ready when configured.</a:t>
+            </a:r>
+          </a:p>
+          <a:p>
+            <a:pPr lvl="0"/>
+            <a:r>
+              <a:rPr/>
+              <a:t>If evidence is weak, abstain explicitly.</a:t>
             </a:r>
           </a:p>
         </p:txBody>
@@ -4554,7 +4964,7 @@
             </a:pPr>
             <a:r>
               <a:rPr/>
-              <a:t>Data Model Logic</a:t>
+              <a:t>Trust And Safety</a:t>
             </a:r>
           </a:p>
         </p:txBody>
@@ -4577,28 +4987,28 @@
             <a:pPr lvl="0"/>
             <a:r>
               <a:rPr/>
-              <a:t>Source governance: approved_repositories -&gt; source_documents -&gt; source_chunks.</a:t>
-            </a:r>
-          </a:p>
-          <a:p>
-            <a:pPr lvl="0"/>
-            <a:r>
-              <a:rPr/>
-              <a:t>FAQ lifecycle: faq_entries -&gt; faq_versions -&gt; review_events.</a:t>
-            </a:r>
-          </a:p>
-          <a:p>
-            <a:pPr lvl="0"/>
-            <a:r>
-              <a:rPr/>
-              <a:t>Runtime telemetry: question_events -&gt; retrieval_events.</a:t>
-            </a:r>
-          </a:p>
-          <a:p>
-            <a:pPr lvl="0"/>
-            <a:r>
-              <a:rPr/>
-              <a:t>Evidence mapping: answer_evidence_links ties answers to source chunks.</a:t>
+              <a:t>Repository allowlist enforces the knowledge boundary.</a:t>
+            </a:r>
+          </a:p>
+          <a:p>
+            <a:pPr lvl="0"/>
+            <a:r>
+              <a:rPr/>
+              <a:t>Generation is limited to retrieved evidence.</a:t>
+            </a:r>
+          </a:p>
+          <a:p>
+            <a:pPr lvl="0"/>
+            <a:r>
+              <a:rPr/>
+              <a:t>Citation gate blocks uncited publication.</a:t>
+            </a:r>
+          </a:p>
+          <a:p>
+            <a:pPr lvl="0"/>
+            <a:r>
+              <a:rPr/>
+              <a:t>Editorial gate controls draft, review, approve, and publish states.</a:t>
             </a:r>
           </a:p>
         </p:txBody>
@@ -4645,7 +5055,7 @@
             </a:pPr>
             <a:r>
               <a:rPr/>
-              <a:t>Why Hallucinations Are Prevented</a:t>
+              <a:t>Functional Requirements Highlights</a:t>
             </a:r>
           </a:p>
         </p:txBody>
@@ -4668,28 +5078,35 @@
             <a:pPr lvl="0"/>
             <a:r>
               <a:rPr/>
-              <a:t>Only approved repositories are retrievable.</a:t>
-            </a:r>
-          </a:p>
-          <a:p>
-            <a:pPr lvl="0"/>
-            <a:r>
-              <a:rPr/>
-              <a:t>Unsupported claims fail citation and support checks.</a:t>
-            </a:r>
-          </a:p>
-          <a:p>
-            <a:pPr lvl="0"/>
-            <a:r>
-              <a:rPr/>
-              <a:t>Evidence links provide claim-to-source traceability.</a:t>
-            </a:r>
-          </a:p>
-          <a:p>
-            <a:pPr lvl="0"/>
-            <a:r>
-              <a:rPr/>
-              <a:t>Unknown questions produce abstention, not speculation.</a:t>
+              <a:t>FR-001: question answering through the helpdesk UI.</a:t>
+            </a:r>
+          </a:p>
+          <a:p>
+            <a:pPr lvl="0"/>
+            <a:r>
+              <a:rPr/>
+              <a:t>FR-004: ingestion and indexing of approved GitHub sources.</a:t>
+            </a:r>
+          </a:p>
+          <a:p>
+            <a:pPr lvl="0"/>
+            <a:r>
+              <a:rPr/>
+              <a:t>FR-005: retrieval and grounded generation.</a:t>
+            </a:r>
+          </a:p>
+          <a:p>
+            <a:pPr lvl="0"/>
+            <a:r>
+              <a:rPr/>
+              <a:t>FR-006: anti-hallucination and boundary enforcement.</a:t>
+            </a:r>
+          </a:p>
+          <a:p>
+            <a:pPr lvl="0"/>
+            <a:r>
+              <a:rPr/>
+              <a:t>FR-002 and FR-003: editorial curation and FAQ promotion.</a:t>
             </a:r>
           </a:p>
         </p:txBody>

</xml_diff>

<commit_message>
Split demo routes and refresh presentation assets
</commit_message>
<xml_diff>
--- a/dist/napcore-helpdesk-presentation.pptx
+++ b/dist/napcore-helpdesk-presentation.pptx
@@ -24,7 +24,6 @@
     <p:sldId id="272" r:id="rId18"/>
     <p:sldId id="273" r:id="rId19"/>
     <p:sldId id="274" r:id="rId20"/>
-    <p:sldId id="275" r:id="rId21"/>
   </p:sldIdLst>
   <p:sldSz cx="9144000" cy="5143500" type="screen16x9"/>
   <p:notesSz cx="6858000" cy="9144000"/>
@@ -3333,7 +3332,7 @@
             </a:pPr>
             <a:r>
               <a:rPr/>
-              <a:t>Why Hallucinations Are Prevented</a:t>
+              <a:t>User Experience Flow</a:t>
             </a:r>
           </a:p>
         </p:txBody>
@@ -3356,28 +3355,62 @@
             <a:pPr lvl="0"/>
             <a:r>
               <a:rPr/>
-              <a:t>Only approved repositories are retrievable.</a:t>
-            </a:r>
-          </a:p>
-          <a:p>
-            <a:pPr lvl="0"/>
-            <a:r>
-              <a:rPr/>
-              <a:t>Unsupported claims fail citation and support checks.</a:t>
-            </a:r>
-          </a:p>
-          <a:p>
-            <a:pPr lvl="0"/>
-            <a:r>
-              <a:rPr/>
-              <a:t>Evidence links provide claim-to-source traceability.</a:t>
-            </a:r>
-          </a:p>
-          <a:p>
-            <a:pPr lvl="0"/>
-            <a:r>
-              <a:rPr/>
-              <a:t>Unknown questions produce abstention, not speculation.</a:t>
+              <a:t>User opens </a:t>
+            </a:r>
+            <a:r>
+              <a:rPr>
+                <a:latin typeface="Courier"/>
+              </a:rPr>
+              <a:t>/user</a:t>
+            </a:r>
+            <a:r>
+              <a:rPr/>
+              <a:t> for conversation or </a:t>
+            </a:r>
+            <a:r>
+              <a:rPr>
+                <a:latin typeface="Courier"/>
+              </a:rPr>
+              <a:t>/operator</a:t>
+            </a:r>
+            <a:r>
+              <a:rPr/>
+              <a:t> for operational review.</a:t>
+            </a:r>
+          </a:p>
+          <a:p>
+            <a:pPr lvl="0"/>
+            <a:r>
+              <a:rPr/>
+              <a:t>System attempts FAQ match first.</a:t>
+            </a:r>
+          </a:p>
+          <a:p>
+            <a:pPr lvl="0"/>
+            <a:r>
+              <a:rPr/>
+              <a:t>On miss or low confidence, the system executes retrieval plus grounded generation.</a:t>
+            </a:r>
+          </a:p>
+          <a:p>
+            <a:pPr lvl="0"/>
+            <a:r>
+              <a:rPr/>
+              <a:t>Response includes references, confidence, and request trace.</a:t>
+            </a:r>
+          </a:p>
+          <a:p>
+            <a:pPr lvl="0"/>
+            <a:r>
+              <a:rPr/>
+              <a:t>Session history supports iterative questioning without losing provenance.</a:t>
+            </a:r>
+          </a:p>
+          <a:p>
+            <a:pPr lvl="0"/>
+            <a:r>
+              <a:rPr/>
+              <a:t>Feedback and editorial routing support continuous improvement.</a:t>
             </a:r>
           </a:p>
         </p:txBody>
@@ -3424,7 +3457,7 @@
             </a:pPr>
             <a:r>
               <a:rPr/>
-              <a:t>User Experience Flow</a:t>
+              <a:t>Current Product State</a:t>
             </a:r>
           </a:p>
         </p:txBody>
@@ -3447,42 +3480,28 @@
             <a:pPr lvl="0"/>
             <a:r>
               <a:rPr/>
-              <a:t>User opens chat session or operator console and submits question.</a:t>
-            </a:r>
-          </a:p>
-          <a:p>
-            <a:pPr lvl="0"/>
-            <a:r>
-              <a:rPr/>
-              <a:t>System attempts FAQ match first.</a:t>
-            </a:r>
-          </a:p>
-          <a:p>
-            <a:pPr lvl="0"/>
-            <a:r>
-              <a:rPr/>
-              <a:t>On miss or low confidence, the system executes retrieval plus grounded generation.</a:t>
-            </a:r>
-          </a:p>
-          <a:p>
-            <a:pPr lvl="0"/>
-            <a:r>
-              <a:rPr/>
-              <a:t>Response includes references, confidence, and request trace.</a:t>
-            </a:r>
-          </a:p>
-          <a:p>
-            <a:pPr lvl="0"/>
-            <a:r>
-              <a:rPr/>
-              <a:t>Session history supports iterative questioning without losing provenance.</a:t>
-            </a:r>
-          </a:p>
-          <a:p>
-            <a:pPr lvl="0"/>
-            <a:r>
-              <a:rPr/>
-              <a:t>Feedback and editorial routing support continuous improvement.</a:t>
+              <a:t>Frontend now exposes separate routed surfaces for user chat and operator console.</a:t>
+            </a:r>
+          </a:p>
+          <a:p>
+            <a:pPr lvl="0"/>
+            <a:r>
+              <a:rPr/>
+              <a:t>Backend supports deterministic grounded generation and an optional LLM-ready mode.</a:t>
+            </a:r>
+          </a:p>
+          <a:p>
+            <a:pPr lvl="0"/>
+            <a:r>
+              <a:rPr/>
+              <a:t>Knowledge index is built from approved repositories and selected companion repositories.</a:t>
+            </a:r>
+          </a:p>
+          <a:p>
+            <a:pPr lvl="0"/>
+            <a:r>
+              <a:rPr/>
+              <a:t>Shared connection state keeps auth and backend targeting consistent across both routes.</a:t>
             </a:r>
           </a:p>
         </p:txBody>
@@ -3519,7 +3538,12 @@
             <p:ph type="title"/>
           </p:nvPr>
         </p:nvSpPr>
-        <p:spPr/>
+        <p:spPr>
+          <a:xfrm>
+            <a:off x="457201" y="204787"/>
+            <a:ext cx="3008313" cy="871538"/>
+          </a:xfrm>
+        </p:spPr>
         <p:txBody>
           <a:bodyPr/>
           <a:lstStyle/>
@@ -3529,55 +3553,91 @@
             </a:pPr>
             <a:r>
               <a:rPr/>
-              <a:t>Current Product State</a:t>
-            </a:r>
-          </a:p>
-        </p:txBody>
-      </p:sp>
-      <p:sp>
-        <p:nvSpPr>
-          <p:cNvPr id="3" name="Content Placeholder 2"/>
-          <p:cNvSpPr>
-            <a:spLocks noGrp="1"/>
-          </p:cNvSpPr>
-          <p:nvPr>
-            <p:ph idx="1"/>
-          </p:nvPr>
-        </p:nvSpPr>
-        <p:spPr/>
-        <p:txBody>
-          <a:bodyPr/>
-          <a:lstStyle/>
-          <a:p>
-            <a:pPr lvl="0"/>
-            <a:r>
-              <a:rPr/>
-              <a:t>Frontend now includes a chat-style session UX alongside the editorial console.</a:t>
-            </a:r>
-          </a:p>
-          <a:p>
-            <a:pPr lvl="0"/>
-            <a:r>
-              <a:rPr/>
-              <a:t>Backend supports deterministic grounded generation and an optional LLM-ready mode.</a:t>
-            </a:r>
-          </a:p>
-          <a:p>
-            <a:pPr lvl="0"/>
-            <a:r>
-              <a:rPr/>
-              <a:t>Knowledge index is built from approved repositories and selected companion repositories.</a:t>
-            </a:r>
-          </a:p>
-          <a:p>
-            <a:pPr lvl="0"/>
-            <a:r>
-              <a:rPr/>
-              <a:t>Editorial board, KPI metrics, and promotion candidate flows remain part of the same product.</a:t>
-            </a:r>
-          </a:p>
-        </p:txBody>
-      </p:sp>
+              <a:t>Current Chat UX</a:t>
+            </a:r>
+          </a:p>
+        </p:txBody>
+      </p:sp>
+      <p:sp>
+        <p:nvSpPr>
+          <p:cNvPr id="4" name="Text Placeholder 3"/>
+          <p:cNvSpPr>
+            <a:spLocks noGrp="1"/>
+          </p:cNvSpPr>
+          <p:nvPr>
+            <p:ph idx="2" sz="half" type="body"/>
+          </p:nvPr>
+        </p:nvSpPr>
+        <p:spPr/>
+        <p:txBody>
+          <a:bodyPr/>
+          <a:lstStyle/>
+          <a:p>
+            <a:pPr lvl="0"/>
+            <a:r>
+              <a:rPr/>
+              <a:t>Live </a:t>
+            </a:r>
+            <a:r>
+              <a:rPr>
+                <a:latin typeface="Courier"/>
+              </a:rPr>
+              <a:t>/user</a:t>
+            </a:r>
+            <a:r>
+              <a:rPr/>
+              <a:t> chat route with per-turn evidence, confidence, and request trace.</a:t>
+            </a:r>
+          </a:p>
+          <a:p>
+            <a:pPr lvl="0"/>
+            <a:r>
+              <a:rPr/>
+              <a:t>Separate </a:t>
+            </a:r>
+            <a:r>
+              <a:rPr>
+                <a:latin typeface="Courier"/>
+              </a:rPr>
+              <a:t>/operator</a:t>
+            </a:r>
+            <a:r>
+              <a:rPr/>
+              <a:t> route handles orchestration, board, KPI, and editorial actions.</a:t>
+            </a:r>
+          </a:p>
+        </p:txBody>
+      </p:sp>
+      <p:pic>
+        <p:nvPicPr>
+          <p:cNvPr descr="docs/presentation/assets/chat-session-ui.png" id="0" name="Picture 1"/>
+          <p:cNvPicPr>
+            <a:picLocks noGrp="1" noChangeAspect="1"/>
+          </p:cNvPicPr>
+          <p:nvPr/>
+        </p:nvPicPr>
+        <p:blipFill>
+          <a:blip r:embed="rId2"/>
+          <a:stretch>
+            <a:fillRect/>
+          </a:stretch>
+        </p:blipFill>
+        <p:spPr bwMode="auto">
+          <a:xfrm>
+            <a:off x="3568700" y="952500"/>
+            <a:ext cx="5105400" cy="2870200"/>
+          </a:xfrm>
+          <a:prstGeom prst="rect">
+            <a:avLst/>
+          </a:prstGeom>
+          <a:noFill/>
+          <a:ln w="9525">
+            <a:noFill/>
+            <a:headEnd/>
+            <a:tailEnd/>
+          </a:ln>
+        </p:spPr>
+      </p:pic>
     </p:spTree>
   </p:cSld>
 </p:sld>
@@ -3610,12 +3670,7 @@
             <p:ph type="title"/>
           </p:nvPr>
         </p:nvSpPr>
-        <p:spPr>
-          <a:xfrm>
-            <a:off x="457201" y="204787"/>
-            <a:ext cx="3008313" cy="871538"/>
-          </a:xfrm>
-        </p:spPr>
+        <p:spPr/>
         <p:txBody>
           <a:bodyPr/>
           <a:lstStyle/>
@@ -3625,71 +3680,62 @@
             </a:pPr>
             <a:r>
               <a:rPr/>
-              <a:t>Current Chat UX</a:t>
-            </a:r>
-          </a:p>
-        </p:txBody>
-      </p:sp>
-      <p:sp>
-        <p:nvSpPr>
-          <p:cNvPr id="4" name="Text Placeholder 3"/>
-          <p:cNvSpPr>
-            <a:spLocks noGrp="1"/>
-          </p:cNvSpPr>
-          <p:nvPr>
-            <p:ph idx="2" sz="half" type="body"/>
-          </p:nvPr>
-        </p:nvSpPr>
-        <p:spPr/>
-        <p:txBody>
-          <a:bodyPr/>
-          <a:lstStyle/>
-          <a:p>
-            <a:pPr lvl="0"/>
-            <a:r>
-              <a:rPr/>
-              <a:t>Live chat session view with per-turn evidence, confidence, and request trace.</a:t>
-            </a:r>
-          </a:p>
-          <a:p>
-            <a:pPr lvl="0"/>
-            <a:r>
-              <a:rPr/>
-              <a:t>Same surface supports deterministic grounded answers today and LLM-ready mode later.</a:t>
-            </a:r>
-          </a:p>
-        </p:txBody>
-      </p:sp>
-      <p:pic>
-        <p:nvPicPr>
-          <p:cNvPr descr="docs/presentation/assets/chat-session-ui.png" id="0" name="Picture 1"/>
-          <p:cNvPicPr>
-            <a:picLocks noGrp="1" noChangeAspect="1"/>
-          </p:cNvPicPr>
-          <p:nvPr/>
-        </p:nvPicPr>
-        <p:blipFill>
-          <a:blip r:embed="rId2"/>
-          <a:stretch>
-            <a:fillRect/>
-          </a:stretch>
-        </p:blipFill>
-        <p:spPr bwMode="auto">
-          <a:xfrm>
-            <a:off x="3568700" y="838200"/>
-            <a:ext cx="5105400" cy="3111500"/>
-          </a:xfrm>
-          <a:prstGeom prst="rect">
-            <a:avLst/>
-          </a:prstGeom>
-          <a:noFill/>
-          <a:ln w="9525">
-            <a:noFill/>
-            <a:headEnd/>
-            <a:tailEnd/>
-          </a:ln>
-        </p:spPr>
-      </p:pic>
+              <a:t>Operations And Governance</a:t>
+            </a:r>
+          </a:p>
+        </p:txBody>
+      </p:sp>
+      <p:sp>
+        <p:nvSpPr>
+          <p:cNvPr id="3" name="Content Placeholder 2"/>
+          <p:cNvSpPr>
+            <a:spLocks noGrp="1"/>
+          </p:cNvSpPr>
+          <p:nvPr>
+            <p:ph idx="1"/>
+          </p:nvPr>
+        </p:nvSpPr>
+        <p:spPr/>
+        <p:txBody>
+          <a:bodyPr/>
+          <a:lstStyle/>
+          <a:p>
+            <a:pPr lvl="0"/>
+            <a:r>
+              <a:rPr/>
+              <a:t>Reviewer decisions are logged and auditable.</a:t>
+            </a:r>
+          </a:p>
+          <a:p>
+            <a:pPr lvl="0"/>
+            <a:r>
+              <a:rPr/>
+              <a:t>Editorial operations run through Django Admin.</a:t>
+            </a:r>
+          </a:p>
+          <a:p>
+            <a:pPr lvl="0"/>
+            <a:r>
+              <a:rPr/>
+              <a:t>Recurring intents are promoted into curated FAQ backlog.</a:t>
+            </a:r>
+          </a:p>
+          <a:p>
+            <a:pPr lvl="0"/>
+            <a:r>
+              <a:rPr/>
+              <a:t>Re-indexing handles source and standards updates.</a:t>
+            </a:r>
+          </a:p>
+          <a:p>
+            <a:pPr lvl="0"/>
+            <a:r>
+              <a:rPr/>
+              <a:t>Metrics monitor quality and safety continuously.</a:t>
+            </a:r>
+          </a:p>
+        </p:txBody>
+      </p:sp>
     </p:spTree>
   </p:cSld>
 </p:sld>
@@ -3732,7 +3778,7 @@
             </a:pPr>
             <a:r>
               <a:rPr/>
-              <a:t>Operations And Governance</a:t>
+              <a:t>MVP Success Metrics</a:t>
             </a:r>
           </a:p>
         </p:txBody>
@@ -3755,35 +3801,28 @@
             <a:pPr lvl="0"/>
             <a:r>
               <a:rPr/>
-              <a:t>Reviewer decisions are logged and auditable.</a:t>
-            </a:r>
-          </a:p>
-          <a:p>
-            <a:pPr lvl="0"/>
-            <a:r>
-              <a:rPr/>
-              <a:t>Editorial operations run through Django Admin.</a:t>
-            </a:r>
-          </a:p>
-          <a:p>
-            <a:pPr lvl="0"/>
-            <a:r>
-              <a:rPr/>
-              <a:t>Recurring intents are promoted into curated FAQ backlog.</a:t>
-            </a:r>
-          </a:p>
-          <a:p>
-            <a:pPr lvl="0"/>
-            <a:r>
-              <a:rPr/>
-              <a:t>Re-indexing handles source and standards updates.</a:t>
-            </a:r>
-          </a:p>
-          <a:p>
-            <a:pPr lvl="0"/>
-            <a:r>
-              <a:rPr/>
-              <a:t>Metrics monitor quality and safety continuously.</a:t>
+              <a:t>Citation coverage for published FAQs: 100%.</a:t>
+            </a:r>
+          </a:p>
+          <a:p>
+            <a:pPr lvl="0"/>
+            <a:r>
+              <a:rPr/>
+              <a:t>Unsupported-claim publication rate: 0%.</a:t>
+            </a:r>
+          </a:p>
+          <a:p>
+            <a:pPr lvl="0"/>
+            <a:r>
+              <a:rPr/>
+              <a:t>P95 latency: &lt;= 8 seconds.</a:t>
+            </a:r>
+          </a:p>
+          <a:p>
+            <a:pPr lvl="0"/>
+            <a:r>
+              <a:rPr/>
+              <a:t>Retrieval success on covered intents: &gt;= 90%.</a:t>
             </a:r>
           </a:p>
         </p:txBody>
@@ -3830,7 +3869,7 @@
             </a:pPr>
             <a:r>
               <a:rPr/>
-              <a:t>MVP Success Metrics</a:t>
+              <a:t>Current Artifacts</a:t>
             </a:r>
           </a:p>
         </p:txBody>
@@ -3853,28 +3892,35 @@
             <a:pPr lvl="0"/>
             <a:r>
               <a:rPr/>
-              <a:t>Citation coverage for published FAQs: 100%.</a:t>
-            </a:r>
-          </a:p>
-          <a:p>
-            <a:pPr lvl="0"/>
-            <a:r>
-              <a:rPr/>
-              <a:t>Unsupported-claim publication rate: 0%.</a:t>
-            </a:r>
-          </a:p>
-          <a:p>
-            <a:pPr lvl="0"/>
-            <a:r>
-              <a:rPr/>
-              <a:t>P95 latency: &lt;= 8 seconds.</a:t>
-            </a:r>
-          </a:p>
-          <a:p>
-            <a:pPr lvl="0"/>
-            <a:r>
-              <a:rPr/>
-              <a:t>Retrieval success on covered intents: &gt;= 90%.</a:t>
+              <a:t>Functional requirements, testing pack, and local run guide.</a:t>
+            </a:r>
+          </a:p>
+          <a:p>
+            <a:pPr lvl="0"/>
+            <a:r>
+              <a:rPr/>
+              <a:t>RAG architecture, database logic, and updated C4 architecture documents.</a:t>
+            </a:r>
+          </a:p>
+          <a:p>
+            <a:pPr lvl="0"/>
+            <a:r>
+              <a:rPr/>
+              <a:t>Technology baseline: Django 5 + DRF backend, React/Vite frontend, editorial workflow.</a:t>
+            </a:r>
+          </a:p>
+          <a:p>
+            <a:pPr lvl="0"/>
+            <a:r>
+              <a:rPr/>
+              <a:t>Separate routed user/operator UX, deterministic grounded answering, and LLM-ready generation adapter.</a:t>
+            </a:r>
+          </a:p>
+          <a:p>
+            <a:pPr lvl="0"/>
+            <a:r>
+              <a:rPr/>
+              <a:t>PlantUML and exported SVG architecture assets for reproducible documentation.</a:t>
             </a:r>
           </a:p>
         </p:txBody>
@@ -3921,7 +3967,7 @@
             </a:pPr>
             <a:r>
               <a:rPr/>
-              <a:t>Current Artifacts</a:t>
+              <a:t>Next Steps</a:t>
             </a:r>
           </a:p>
         </p:txBody>
@@ -3941,38 +3987,39 @@
           <a:bodyPr/>
           <a:lstStyle/>
           <a:p>
-            <a:pPr lvl="0"/>
-            <a:r>
-              <a:rPr/>
-              <a:t>Functional requirements, testing pack, and local run guide.</a:t>
-            </a:r>
-          </a:p>
-          <a:p>
-            <a:pPr lvl="0"/>
-            <a:r>
-              <a:rPr/>
-              <a:t>RAG architecture, database logic, and updated C4 architecture documents.</a:t>
-            </a:r>
-          </a:p>
-          <a:p>
-            <a:pPr lvl="0"/>
-            <a:r>
-              <a:rPr/>
-              <a:t>Technology baseline: Django 5 + DRF backend, React/Vite frontend, editorial workflow.</a:t>
-            </a:r>
-          </a:p>
-          <a:p>
-            <a:pPr lvl="0"/>
-            <a:r>
-              <a:rPr/>
-              <a:t>Chat session UX, deterministic grounded answering, and LLM-ready generation adapter.</a:t>
-            </a:r>
-          </a:p>
-          <a:p>
-            <a:pPr lvl="0"/>
-            <a:r>
-              <a:rPr/>
-              <a:t>PlantUML and exported SVG architecture assets for reproducible documentation.</a:t>
+            <a:pPr lvl="0" indent="-342900" marL="342900">
+              <a:buAutoNum type="arabicPeriod"/>
+            </a:pPr>
+            <a:r>
+              <a:rPr/>
+              <a:t>Complete pilot testing across chat UX, editorial workflow, and promotion flows.</a:t>
+            </a:r>
+          </a:p>
+          <a:p>
+            <a:pPr lvl="0" indent="-342900" marL="342900">
+              <a:buAutoNum type="arabicPeriod"/>
+            </a:pPr>
+            <a:r>
+              <a:rPr/>
+              <a:t>Enable and evaluate grounded LLM mode against deterministic fallback behavior.</a:t>
+            </a:r>
+          </a:p>
+          <a:p>
+            <a:pPr lvl="0" indent="-342900" marL="342900">
+              <a:buAutoNum type="arabicPeriod"/>
+            </a:pPr>
+            <a:r>
+              <a:rPr/>
+              <a:t>Refine ingestion profiles for companion repositories and standards-specific scopes.</a:t>
+            </a:r>
+          </a:p>
+          <a:p>
+            <a:pPr lvl="0" indent="-342900" marL="342900">
+              <a:buAutoNum type="arabicPeriod"/>
+            </a:pPr>
+            <a:r>
+              <a:rPr/>
+              <a:t>Use pilot evidence to decide production hardening and deployment model.</a:t>
             </a:r>
           </a:p>
         </p:txBody>
@@ -4019,7 +4066,7 @@
             </a:pPr>
             <a:r>
               <a:rPr/>
-              <a:t>Next Steps</a:t>
+              <a:t>Appendix: Example Questions</a:t>
             </a:r>
           </a:p>
         </p:txBody>
@@ -4039,39 +4086,26 @@
           <a:bodyPr/>
           <a:lstStyle/>
           <a:p>
-            <a:pPr lvl="0" indent="-342900" marL="342900">
-              <a:buAutoNum type="arabicPeriod"/>
+            <a:pPr lvl="0"/>
+            <a:r>
+              <a:rPr/>
+              <a:t>How to use NeTEx for exchanging a timetable?</a:t>
+            </a:r>
+          </a:p>
+          <a:p>
+            <a:pPr lvl="0"/>
+            <a:r>
+              <a:rPr/>
+              <a:t>How to implement IDs for a Stop Place registry?</a:t>
+            </a:r>
+          </a:p>
+          <a:p>
+            <a:pPr lvl="0" indent="0" marL="0">
+              <a:buNone/>
             </a:pPr>
             <a:r>
               <a:rPr/>
-              <a:t>Complete pilot testing across chat UX, editorial workflow, and promotion flows.</a:t>
-            </a:r>
-          </a:p>
-          <a:p>
-            <a:pPr lvl="0" indent="-342900" marL="342900">
-              <a:buAutoNum type="arabicPeriod"/>
-            </a:pPr>
-            <a:r>
-              <a:rPr/>
-              <a:t>Enable and evaluate grounded LLM mode against deterministic fallback behavior.</a:t>
-            </a:r>
-          </a:p>
-          <a:p>
-            <a:pPr lvl="0" indent="-342900" marL="342900">
-              <a:buAutoNum type="arabicPeriod"/>
-            </a:pPr>
-            <a:r>
-              <a:rPr/>
-              <a:t>Refine ingestion profiles for companion repositories and standards-specific scopes.</a:t>
-            </a:r>
-          </a:p>
-          <a:p>
-            <a:pPr lvl="0" indent="-342900" marL="342900">
-              <a:buAutoNum type="arabicPeriod"/>
-            </a:pPr>
-            <a:r>
-              <a:rPr/>
-              <a:t>Use pilot evidence to decide production hardening and deployment model.</a:t>
+              <a:t>Expected outputs: - practical implementation guidance, - explicit citations, - abstention where evidence is insufficient.</a:t>
             </a:r>
           </a:p>
         </p:txBody>
@@ -4118,7 +4152,7 @@
             </a:pPr>
             <a:r>
               <a:rPr/>
-              <a:t>Appendix: Example Questions</a:t>
+              <a:t>Notes</a:t>
             </a:r>
           </a:p>
         </p:txBody>
@@ -4138,26 +4172,12 @@
           <a:bodyPr/>
           <a:lstStyle/>
           <a:p>
-            <a:pPr lvl="0"/>
-            <a:r>
-              <a:rPr/>
-              <a:t>How to use NeTEx for exchanging a timetable?</a:t>
-            </a:r>
-          </a:p>
-          <a:p>
-            <a:pPr lvl="0"/>
-            <a:r>
-              <a:rPr/>
-              <a:t>How to implement IDs for a Stop Place registry?</a:t>
-            </a:r>
-          </a:p>
-          <a:p>
             <a:pPr lvl="0" indent="0" marL="0">
               <a:buNone/>
             </a:pPr>
             <a:r>
-              <a:rPr/>
-              <a:t>Expected outputs: - practical implementation guidance, - explicit citations, - abstention where evidence is insufficient.</a:t>
+              <a:rPr sz="1800"/>
+              <a:t>1. RAG fallback means that when no high-confidence FAQ answer is available, the system retrieves relevant source chunks and then generates an answer grounded in that retrieved evidence.</a:t>
             </a:r>
           </a:p>
         </p:txBody>
@@ -4242,78 +4262,6 @@
             <a:r>
               <a:rPr/>
               <a:t>Goal is practical answers with traceable references and controlled escalation.</a:t>
-            </a:r>
-          </a:p>
-        </p:txBody>
-      </p:sp>
-    </p:spTree>
-  </p:cSld>
-</p:sld>
-</file>
-
-<file path=ppt/slides/slide20.xml><?xml version="1.0" encoding="utf-8"?>
-<p:sld xmlns:a="http://schemas.openxmlformats.org/drawingml/2006/main" xmlns:r="http://schemas.openxmlformats.org/officeDocument/2006/relationships" xmlns:p="http://schemas.openxmlformats.org/presentationml/2006/main">
-  <p:cSld>
-    <p:spTree>
-      <p:nvGrpSpPr>
-        <p:cNvPr id="1" name=""/>
-        <p:cNvGrpSpPr/>
-        <p:nvPr/>
-      </p:nvGrpSpPr>
-      <p:grpSpPr>
-        <a:xfrm>
-          <a:off x="0" y="0"/>
-          <a:ext cx="0" cy="0"/>
-          <a:chOff x="0" y="0"/>
-          <a:chExt cx="0" cy="0"/>
-        </a:xfrm>
-      </p:grpSpPr>
-      <p:sp>
-        <p:nvSpPr>
-          <p:cNvPr id="2" name="Title 1"/>
-          <p:cNvSpPr>
-            <a:spLocks noGrp="1"/>
-          </p:cNvSpPr>
-          <p:nvPr>
-            <p:ph type="title"/>
-          </p:nvPr>
-        </p:nvSpPr>
-        <p:spPr/>
-        <p:txBody>
-          <a:bodyPr/>
-          <a:lstStyle/>
-          <a:p>
-            <a:pPr lvl="0" indent="0" marL="0">
-              <a:buNone/>
-            </a:pPr>
-            <a:r>
-              <a:rPr/>
-              <a:t>Notes</a:t>
-            </a:r>
-          </a:p>
-        </p:txBody>
-      </p:sp>
-      <p:sp>
-        <p:nvSpPr>
-          <p:cNvPr id="3" name="Content Placeholder 2"/>
-          <p:cNvSpPr>
-            <a:spLocks noGrp="1"/>
-          </p:cNvSpPr>
-          <p:nvPr>
-            <p:ph idx="1"/>
-          </p:nvPr>
-        </p:nvSpPr>
-        <p:spPr/>
-        <p:txBody>
-          <a:bodyPr/>
-          <a:lstStyle/>
-          <a:p>
-            <a:pPr lvl="0" indent="0" marL="0">
-              <a:buNone/>
-            </a:pPr>
-            <a:r>
-              <a:rPr sz="1800"/>
-              <a:t>1. RAG fallback means that when no high-confidence FAQ answer is available, the system retrieves relevant source chunks and then generates an answer grounded in that retrieved evidence.</a:t>
             </a:r>
           </a:p>
         </p:txBody>
@@ -4617,7 +4565,27 @@
             <a:pPr lvl="0"/>
             <a:r>
               <a:rPr/>
-              <a:t>User channel: one operator console with a chat-style helpdesk experience.</a:t>
+              <a:t>Demo surfaces are now split into </a:t>
+            </a:r>
+            <a:r>
+              <a:rPr>
+                <a:latin typeface="Courier"/>
+              </a:rPr>
+              <a:t>/user</a:t>
+            </a:r>
+            <a:r>
+              <a:rPr/>
+              <a:t> and </a:t>
+            </a:r>
+            <a:r>
+              <a:rPr>
+                <a:latin typeface="Courier"/>
+              </a:rPr>
+              <a:t>/operator</a:t>
+            </a:r>
+            <a:r>
+              <a:rPr/>
+              <a:t> routes over one shared backend/session shell.</a:t>
             </a:r>
           </a:p>
         </p:txBody>

</xml_diff>

<commit_message>
Enhance deterministic generator with pattern-matching and clarify generation profiles in presentations
</commit_message>
<xml_diff>
--- a/dist/napcore-helpdesk-presentation.pptx
+++ b/dist/napcore-helpdesk-presentation.pptx
@@ -4177,7 +4177,23 @@
             </a:pPr>
             <a:r>
               <a:rPr sz="1800"/>
-              <a:t>1. In a helpdesk or FAQ system, a RAG fallback (Retrieval‑Augmented Generation) happens when the system cannot find a good direct match (e.g., exact FAQ answer). It then falls back to RAG: retrieves the most relevant documents (FAQs, articles, knowledge base), feeds them into an LLM, and generates an answer based on retrieved context. This allows the assistant to give a relevant answer without hallucinating by grounding the response in real text.</a:t>
+              <a:t>1. In a helpdesk or FAQ system, a RAG fallback (Retrieval‑Augmented Generation) happens when the system cannot find a good direct match (e.g., exact FAQ answer). It then falls back to RAG: retrieves the most relevant documents from approved sources, and generates an answer grounded in that retrieved context. The generation method depends on the profile: (1) </a:t>
+            </a:r>
+            <a:r>
+              <a:rPr sz="1800" b="1"/>
+              <a:t>Deterministic mode</a:t>
+            </a:r>
+            <a:r>
+              <a:rPr sz="1800"/>
+              <a:t> (now): uses pattern-matched templates adapted to the question, with confidence based on retrieval scores. (2) </a:t>
+            </a:r>
+            <a:r>
+              <a:rPr sz="1800" b="1"/>
+              <a:t>LLM-ready mode</a:t>
+            </a:r>
+            <a:r>
+              <a:rPr sz="1800"/>
+              <a:t> (future): feeds retrieved chunks to an LLM for synthesis. Both approaches prevent hallucination by grounding answers in real retrieved text.</a:t>
             </a:r>
           </a:p>
         </p:txBody>
@@ -4871,7 +4887,7 @@
             <a:pPr lvl="0"/>
             <a:r>
               <a:rPr/>
-              <a:t>RAG fallback: retrieve source chunks, then generate a grounded answer.</a:t>
+              <a:t>RAG fallback: retrieve source chunks, then generate a grounded answer (deterministic templates now, LLM synthesis when enabled).</a:t>
             </a:r>
           </a:p>
           <a:p>

</xml_diff>

<commit_message>
Restructure deck and refresh UX/question screenshots
</commit_message>
<xml_diff>
--- a/dist/napcore-helpdesk-presentation.pptx
+++ b/dist/napcore-helpdesk-presentation.pptx
@@ -19,11 +19,6 @@
     <p:sldId id="267" r:id="rId13"/>
     <p:sldId id="268" r:id="rId14"/>
     <p:sldId id="269" r:id="rId15"/>
-    <p:sldId id="270" r:id="rId16"/>
-    <p:sldId id="271" r:id="rId17"/>
-    <p:sldId id="272" r:id="rId18"/>
-    <p:sldId id="273" r:id="rId19"/>
-    <p:sldId id="274" r:id="rId20"/>
   </p:sldIdLst>
   <p:sldSz cx="9144000" cy="5143500" type="screen16x9"/>
   <p:notesSz cx="6858000" cy="9144000"/>
@@ -3133,7 +3128,7 @@
             </a:pPr>
             <a:r>
               <a:rPr/>
-              <a:t>NAPCORE Helpdesk: From Search To Grounded Chat Helpdesk</a:t>
+              <a:t>NAPCORE Helpdesk: requirements and development</a:t>
             </a:r>
           </a:p>
         </p:txBody>
@@ -3194,7 +3189,7 @@
             </a:pPr>
             <a:r>
               <a:rPr/>
-              <a:t>2026-03-28</a:t>
+              <a:t>2026-03-29</a:t>
             </a:r>
           </a:p>
         </p:txBody>
@@ -3241,7 +3236,7 @@
             </a:pPr>
             <a:r>
               <a:rPr/>
-              <a:t>Data Model Logic</a:t>
+              <a:t>Documentation And Delivery Artifacts</a:t>
             </a:r>
           </a:p>
         </p:txBody>
@@ -3264,28 +3259,35 @@
             <a:pPr lvl="0"/>
             <a:r>
               <a:rPr/>
-              <a:t>Source governance: approved_repositories -&gt; source_documents -&gt; source_chunks.</a:t>
+              <a:t>Functional requirements, testing pack, and local run guide.</a:t>
             </a:r>
           </a:p>
           <a:p>
             <a:pPr lvl="0"/>
             <a:r>
               <a:rPr/>
-              <a:t>FAQ lifecycle: faq_entries -&gt; faq_versions -&gt; review_events.</a:t>
+              <a:t>RAG architecture and updated C4 architecture documents.</a:t>
             </a:r>
           </a:p>
           <a:p>
             <a:pPr lvl="0"/>
             <a:r>
               <a:rPr/>
-              <a:t>Runtime telemetry: question_events -&gt; retrieval_events.</a:t>
+              <a:t>Technology baseline: Django 5 + DRF backend, React/Vite frontend.</a:t>
             </a:r>
           </a:p>
           <a:p>
             <a:pPr lvl="0"/>
             <a:r>
               <a:rPr/>
-              <a:t>Evidence mapping: answer_evidence_links ties answers to source chunks.</a:t>
+              <a:t>Separate routed user/operator UX and deterministic grounded answering.</a:t>
+            </a:r>
+          </a:p>
+          <a:p>
+            <a:pPr lvl="0"/>
+            <a:r>
+              <a:rPr/>
+              <a:t>PlantUML and exported SVG architecture assets for reproducible documentation.</a:t>
             </a:r>
           </a:p>
         </p:txBody>
@@ -3332,7 +3334,7 @@
             </a:pPr>
             <a:r>
               <a:rPr/>
-              <a:t>User Experience Flow</a:t>
+              <a:t>Next Steps</a:t>
             </a:r>
           </a:p>
         </p:txBody>
@@ -3352,65 +3354,30 @@
           <a:bodyPr/>
           <a:lstStyle/>
           <a:p>
-            <a:pPr lvl="0"/>
-            <a:r>
-              <a:rPr/>
-              <a:t>User opens </a:t>
-            </a:r>
-            <a:r>
-              <a:rPr>
-                <a:latin typeface="Courier"/>
-              </a:rPr>
-              <a:t>/user</a:t>
-            </a:r>
-            <a:r>
-              <a:rPr/>
-              <a:t> for conversation or </a:t>
-            </a:r>
-            <a:r>
-              <a:rPr>
-                <a:latin typeface="Courier"/>
-              </a:rPr>
-              <a:t>/operator</a:t>
-            </a:r>
-            <a:r>
-              <a:rPr/>
-              <a:t> for operational review.</a:t>
-            </a:r>
-          </a:p>
-          <a:p>
-            <a:pPr lvl="0"/>
-            <a:r>
-              <a:rPr/>
-              <a:t>System attempts FAQ match first.</a:t>
-            </a:r>
-          </a:p>
-          <a:p>
-            <a:pPr lvl="0"/>
-            <a:r>
-              <a:rPr/>
-              <a:t>On miss or low confidence, the system executes retrieval plus grounded generation.</a:t>
-            </a:r>
-          </a:p>
-          <a:p>
-            <a:pPr lvl="0"/>
-            <a:r>
-              <a:rPr/>
-              <a:t>Response includes references, confidence, and request trace.</a:t>
-            </a:r>
-          </a:p>
-          <a:p>
-            <a:pPr lvl="0"/>
-            <a:r>
-              <a:rPr/>
-              <a:t>Session history supports iterative questioning without losing provenance.</a:t>
-            </a:r>
-          </a:p>
-          <a:p>
-            <a:pPr lvl="0"/>
-            <a:r>
-              <a:rPr/>
-              <a:t>Feedback and editorial routing support continuous improvement.</a:t>
+            <a:pPr lvl="0" indent="-342900" marL="342900">
+              <a:buAutoNum type="arabicPeriod"/>
+            </a:pPr>
+            <a:r>
+              <a:rPr/>
+              <a:t>Complete pilot testing across user chat, operator flow, and promotion workflow.</a:t>
+            </a:r>
+          </a:p>
+          <a:p>
+            <a:pPr lvl="0" indent="-342900" marL="342900">
+              <a:buAutoNum type="arabicPeriod"/>
+            </a:pPr>
+            <a:r>
+              <a:rPr/>
+              <a:t>Evaluate deterministic mode outcomes against grounded LLM mode on the same question set.</a:t>
+            </a:r>
+          </a:p>
+          <a:p>
+            <a:pPr lvl="0" indent="-342900" marL="342900">
+              <a:buAutoNum type="arabicPeriod"/>
+            </a:pPr>
+            <a:r>
+              <a:rPr/>
+              <a:t>Finalize repository ingestion profiles and production hardening backlog.</a:t>
             </a:r>
           </a:p>
         </p:txBody>
@@ -3447,7 +3414,12 @@
             <p:ph type="title"/>
           </p:nvPr>
         </p:nvSpPr>
-        <p:spPr/>
+        <p:spPr>
+          <a:xfrm>
+            <a:off x="457201" y="204787"/>
+            <a:ext cx="3008313" cy="871538"/>
+          </a:xfrm>
+        </p:spPr>
         <p:txBody>
           <a:bodyPr/>
           <a:lstStyle/>
@@ -3457,55 +3429,70 @@
             </a:pPr>
             <a:r>
               <a:rPr/>
-              <a:t>Current Product State</a:t>
-            </a:r>
-          </a:p>
-        </p:txBody>
-      </p:sp>
-      <p:sp>
-        <p:nvSpPr>
-          <p:cNvPr id="3" name="Content Placeholder 2"/>
-          <p:cNvSpPr>
-            <a:spLocks noGrp="1"/>
-          </p:cNvSpPr>
-          <p:nvPr>
-            <p:ph idx="1"/>
-          </p:nvPr>
-        </p:nvSpPr>
-        <p:spPr/>
-        <p:txBody>
-          <a:bodyPr/>
-          <a:lstStyle/>
-          <a:p>
-            <a:pPr lvl="0"/>
-            <a:r>
-              <a:rPr/>
-              <a:t>Frontend now exposes separate routed surfaces for user chat and operator console.</a:t>
-            </a:r>
-          </a:p>
-          <a:p>
-            <a:pPr lvl="0"/>
-            <a:r>
-              <a:rPr/>
-              <a:t>Backend supports deterministic grounded generation and an optional LLM-ready mode.</a:t>
-            </a:r>
-          </a:p>
-          <a:p>
-            <a:pPr lvl="0"/>
-            <a:r>
-              <a:rPr/>
-              <a:t>Knowledge index is built from approved repositories and selected companion repositories.</a:t>
-            </a:r>
-          </a:p>
-          <a:p>
-            <a:pPr lvl="0"/>
-            <a:r>
-              <a:rPr/>
-              <a:t>Shared connection state keeps auth and backend targeting consistent across both routes.</a:t>
-            </a:r>
-          </a:p>
-        </p:txBody>
-      </p:sp>
+              <a:t>Appendix: Example Questions</a:t>
+            </a:r>
+          </a:p>
+        </p:txBody>
+      </p:sp>
+      <p:sp>
+        <p:nvSpPr>
+          <p:cNvPr id="4" name="Text Placeholder 3"/>
+          <p:cNvSpPr>
+            <a:spLocks noGrp="1"/>
+          </p:cNvSpPr>
+          <p:nvPr>
+            <p:ph idx="2" sz="half" type="body"/>
+          </p:nvPr>
+        </p:nvSpPr>
+        <p:spPr/>
+        <p:txBody>
+          <a:bodyPr/>
+          <a:lstStyle/>
+          <a:p>
+            <a:pPr lvl="0" indent="0" marL="0">
+              <a:buNone/>
+            </a:pPr>
+            <a:r>
+              <a:rPr b="1"/>
+              <a:t>Question 1:</a:t>
+            </a:r>
+            <a:r>
+              <a:rPr/>
+              <a:t> How to use NeTEx for exchanging a timetable?</a:t>
+            </a:r>
+          </a:p>
+        </p:txBody>
+      </p:sp>
+      <p:pic>
+        <p:nvPicPr>
+          <p:cNvPr descr="docs/presentation/assets/question-timetable.png" id="0" name="Picture 1"/>
+          <p:cNvPicPr>
+            <a:picLocks noGrp="1" noChangeAspect="1"/>
+          </p:cNvPicPr>
+          <p:nvPr/>
+        </p:nvPicPr>
+        <p:blipFill>
+          <a:blip r:embed="rId2"/>
+          <a:stretch>
+            <a:fillRect/>
+          </a:stretch>
+        </p:blipFill>
+        <p:spPr bwMode="auto">
+          <a:xfrm>
+            <a:off x="3568700" y="952500"/>
+            <a:ext cx="5105400" cy="2870200"/>
+          </a:xfrm>
+          <a:prstGeom prst="rect">
+            <a:avLst/>
+          </a:prstGeom>
+          <a:noFill/>
+          <a:ln w="9525">
+            <a:noFill/>
+            <a:headEnd/>
+            <a:tailEnd/>
+          </a:ln>
+        </p:spPr>
+      </p:pic>
     </p:spTree>
   </p:cSld>
 </p:sld>
@@ -3530,20 +3517,15 @@
       </p:grpSpPr>
       <p:sp>
         <p:nvSpPr>
-          <p:cNvPr id="2" name="Title 1"/>
-          <p:cNvSpPr>
-            <a:spLocks noGrp="1"/>
-          </p:cNvSpPr>
-          <p:nvPr>
-            <p:ph type="title"/>
-          </p:nvPr>
-        </p:nvSpPr>
-        <p:spPr>
-          <a:xfrm>
-            <a:off x="457201" y="204787"/>
-            <a:ext cx="3008313" cy="871538"/>
-          </a:xfrm>
-        </p:spPr>
+          <p:cNvPr id="4" name="Text Placeholder 3"/>
+          <p:cNvSpPr>
+            <a:spLocks noGrp="1"/>
+          </p:cNvSpPr>
+          <p:nvPr>
+            <p:ph idx="2" sz="half" type="body"/>
+          </p:nvPr>
+        </p:nvSpPr>
+        <p:spPr/>
         <p:txBody>
           <a:bodyPr/>
           <a:lstStyle/>
@@ -3552,65 +3534,19 @@
               <a:buNone/>
             </a:pPr>
             <a:r>
-              <a:rPr/>
-              <a:t>Current Chat UX</a:t>
-            </a:r>
-          </a:p>
-        </p:txBody>
-      </p:sp>
-      <p:sp>
-        <p:nvSpPr>
-          <p:cNvPr id="4" name="Text Placeholder 3"/>
-          <p:cNvSpPr>
-            <a:spLocks noGrp="1"/>
-          </p:cNvSpPr>
-          <p:nvPr>
-            <p:ph idx="2" sz="half" type="body"/>
-          </p:nvPr>
-        </p:nvSpPr>
-        <p:spPr/>
-        <p:txBody>
-          <a:bodyPr/>
-          <a:lstStyle/>
-          <a:p>
-            <a:pPr lvl="0"/>
-            <a:r>
-              <a:rPr/>
-              <a:t>Live </a:t>
-            </a:r>
-            <a:r>
-              <a:rPr>
-                <a:latin typeface="Courier"/>
-              </a:rPr>
-              <a:t>/user</a:t>
-            </a:r>
-            <a:r>
-              <a:rPr/>
-              <a:t> chat route with per-turn evidence, confidence, and request trace.</a:t>
-            </a:r>
-          </a:p>
-          <a:p>
-            <a:pPr lvl="0"/>
-            <a:r>
-              <a:rPr/>
-              <a:t>Separate </a:t>
-            </a:r>
-            <a:r>
-              <a:rPr>
-                <a:latin typeface="Courier"/>
-              </a:rPr>
-              <a:t>/operator</a:t>
-            </a:r>
-            <a:r>
-              <a:rPr/>
-              <a:t> route handles orchestration, board, KPI, and editorial actions.</a:t>
+              <a:rPr b="1"/>
+              <a:t>Question 2:</a:t>
+            </a:r>
+            <a:r>
+              <a:rPr/>
+              <a:t> How to implement IDs for a Stop Place registry?</a:t>
             </a:r>
           </a:p>
         </p:txBody>
       </p:sp>
       <p:pic>
         <p:nvPicPr>
-          <p:cNvPr descr="docs/presentation/assets/chat-session-ui.png" id="0" name="Picture 1"/>
+          <p:cNvPr descr="docs/presentation/assets/question-stop-place-ids.png" id="0" name="Picture 1"/>
           <p:cNvPicPr>
             <a:picLocks noGrp="1" noChangeAspect="1"/>
           </p:cNvPicPr>
@@ -3680,7 +3616,7 @@
             </a:pPr>
             <a:r>
               <a:rPr/>
-              <a:t>Operations And Governance</a:t>
+              <a:t>Notes</a:t>
             </a:r>
           </a:p>
         </p:txBody>
@@ -3700,500 +3636,12 @@
           <a:bodyPr/>
           <a:lstStyle/>
           <a:p>
-            <a:pPr lvl="0"/>
-            <a:r>
-              <a:rPr/>
-              <a:t>Reviewer decisions are logged and auditable.</a:t>
-            </a:r>
-          </a:p>
-          <a:p>
-            <a:pPr lvl="0"/>
-            <a:r>
-              <a:rPr/>
-              <a:t>Editorial operations run through Django Admin.</a:t>
-            </a:r>
-          </a:p>
-          <a:p>
-            <a:pPr lvl="0"/>
-            <a:r>
-              <a:rPr/>
-              <a:t>Recurring intents are promoted into curated FAQ backlog.</a:t>
-            </a:r>
-          </a:p>
-          <a:p>
-            <a:pPr lvl="0"/>
-            <a:r>
-              <a:rPr/>
-              <a:t>Re-indexing handles source and standards updates.</a:t>
-            </a:r>
-          </a:p>
-          <a:p>
-            <a:pPr lvl="0"/>
-            <a:r>
-              <a:rPr/>
-              <a:t>Metrics monitor quality and safety continuously.</a:t>
-            </a:r>
-          </a:p>
-        </p:txBody>
-      </p:sp>
-    </p:spTree>
-  </p:cSld>
-</p:sld>
-</file>
-
-<file path=ppt/slides/slide15.xml><?xml version="1.0" encoding="utf-8"?>
-<p:sld xmlns:a="http://schemas.openxmlformats.org/drawingml/2006/main" xmlns:r="http://schemas.openxmlformats.org/officeDocument/2006/relationships" xmlns:p="http://schemas.openxmlformats.org/presentationml/2006/main">
-  <p:cSld>
-    <p:spTree>
-      <p:nvGrpSpPr>
-        <p:cNvPr id="1" name=""/>
-        <p:cNvGrpSpPr/>
-        <p:nvPr/>
-      </p:nvGrpSpPr>
-      <p:grpSpPr>
-        <a:xfrm>
-          <a:off x="0" y="0"/>
-          <a:ext cx="0" cy="0"/>
-          <a:chOff x="0" y="0"/>
-          <a:chExt cx="0" cy="0"/>
-        </a:xfrm>
-      </p:grpSpPr>
-      <p:sp>
-        <p:nvSpPr>
-          <p:cNvPr id="2" name="Title 1"/>
-          <p:cNvSpPr>
-            <a:spLocks noGrp="1"/>
-          </p:cNvSpPr>
-          <p:nvPr>
-            <p:ph type="title"/>
-          </p:nvPr>
-        </p:nvSpPr>
-        <p:spPr/>
-        <p:txBody>
-          <a:bodyPr/>
-          <a:lstStyle/>
-          <a:p>
             <a:pPr lvl="0" indent="0" marL="0">
               <a:buNone/>
             </a:pPr>
             <a:r>
-              <a:rPr/>
-              <a:t>MVP Success Metrics</a:t>
-            </a:r>
-          </a:p>
-        </p:txBody>
-      </p:sp>
-      <p:sp>
-        <p:nvSpPr>
-          <p:cNvPr id="3" name="Content Placeholder 2"/>
-          <p:cNvSpPr>
-            <a:spLocks noGrp="1"/>
-          </p:cNvSpPr>
-          <p:nvPr>
-            <p:ph idx="1"/>
-          </p:nvPr>
-        </p:nvSpPr>
-        <p:spPr/>
-        <p:txBody>
-          <a:bodyPr/>
-          <a:lstStyle/>
-          <a:p>
-            <a:pPr lvl="0"/>
-            <a:r>
-              <a:rPr/>
-              <a:t>Citation coverage for published FAQs: 100%.</a:t>
-            </a:r>
-          </a:p>
-          <a:p>
-            <a:pPr lvl="0"/>
-            <a:r>
-              <a:rPr/>
-              <a:t>Unsupported-claim publication rate: 0%.</a:t>
-            </a:r>
-          </a:p>
-          <a:p>
-            <a:pPr lvl="0"/>
-            <a:r>
-              <a:rPr/>
-              <a:t>P95 latency: &lt;= 8 seconds.</a:t>
-            </a:r>
-          </a:p>
-          <a:p>
-            <a:pPr lvl="0"/>
-            <a:r>
-              <a:rPr/>
-              <a:t>Retrieval success on covered intents: &gt;= 90%.</a:t>
-            </a:r>
-          </a:p>
-        </p:txBody>
-      </p:sp>
-    </p:spTree>
-  </p:cSld>
-</p:sld>
-</file>
-
-<file path=ppt/slides/slide16.xml><?xml version="1.0" encoding="utf-8"?>
-<p:sld xmlns:a="http://schemas.openxmlformats.org/drawingml/2006/main" xmlns:r="http://schemas.openxmlformats.org/officeDocument/2006/relationships" xmlns:p="http://schemas.openxmlformats.org/presentationml/2006/main">
-  <p:cSld>
-    <p:spTree>
-      <p:nvGrpSpPr>
-        <p:cNvPr id="1" name=""/>
-        <p:cNvGrpSpPr/>
-        <p:nvPr/>
-      </p:nvGrpSpPr>
-      <p:grpSpPr>
-        <a:xfrm>
-          <a:off x="0" y="0"/>
-          <a:ext cx="0" cy="0"/>
-          <a:chOff x="0" y="0"/>
-          <a:chExt cx="0" cy="0"/>
-        </a:xfrm>
-      </p:grpSpPr>
-      <p:sp>
-        <p:nvSpPr>
-          <p:cNvPr id="2" name="Title 1"/>
-          <p:cNvSpPr>
-            <a:spLocks noGrp="1"/>
-          </p:cNvSpPr>
-          <p:nvPr>
-            <p:ph type="title"/>
-          </p:nvPr>
-        </p:nvSpPr>
-        <p:spPr/>
-        <p:txBody>
-          <a:bodyPr/>
-          <a:lstStyle/>
-          <a:p>
-            <a:pPr lvl="0" indent="0" marL="0">
-              <a:buNone/>
-            </a:pPr>
-            <a:r>
-              <a:rPr/>
-              <a:t>Current Artifacts</a:t>
-            </a:r>
-          </a:p>
-        </p:txBody>
-      </p:sp>
-      <p:sp>
-        <p:nvSpPr>
-          <p:cNvPr id="3" name="Content Placeholder 2"/>
-          <p:cNvSpPr>
-            <a:spLocks noGrp="1"/>
-          </p:cNvSpPr>
-          <p:nvPr>
-            <p:ph idx="1"/>
-          </p:nvPr>
-        </p:nvSpPr>
-        <p:spPr/>
-        <p:txBody>
-          <a:bodyPr/>
-          <a:lstStyle/>
-          <a:p>
-            <a:pPr lvl="0"/>
-            <a:r>
-              <a:rPr/>
-              <a:t>Functional requirements, testing pack, and local run guide.</a:t>
-            </a:r>
-          </a:p>
-          <a:p>
-            <a:pPr lvl="0"/>
-            <a:r>
-              <a:rPr/>
-              <a:t>RAG architecture, database logic, and updated C4 architecture documents.</a:t>
-            </a:r>
-          </a:p>
-          <a:p>
-            <a:pPr lvl="0"/>
-            <a:r>
-              <a:rPr/>
-              <a:t>Technology baseline: Django 5 + DRF backend, React/Vite frontend, editorial workflow.</a:t>
-            </a:r>
-          </a:p>
-          <a:p>
-            <a:pPr lvl="0"/>
-            <a:r>
-              <a:rPr/>
-              <a:t>Separate routed user/operator UX, deterministic grounded answering, and LLM-ready generation adapter.</a:t>
-            </a:r>
-          </a:p>
-          <a:p>
-            <a:pPr lvl="0"/>
-            <a:r>
-              <a:rPr/>
-              <a:t>PlantUML and exported SVG architecture assets for reproducible documentation.</a:t>
-            </a:r>
-          </a:p>
-        </p:txBody>
-      </p:sp>
-    </p:spTree>
-  </p:cSld>
-</p:sld>
-</file>
-
-<file path=ppt/slides/slide17.xml><?xml version="1.0" encoding="utf-8"?>
-<p:sld xmlns:a="http://schemas.openxmlformats.org/drawingml/2006/main" xmlns:r="http://schemas.openxmlformats.org/officeDocument/2006/relationships" xmlns:p="http://schemas.openxmlformats.org/presentationml/2006/main">
-  <p:cSld>
-    <p:spTree>
-      <p:nvGrpSpPr>
-        <p:cNvPr id="1" name=""/>
-        <p:cNvGrpSpPr/>
-        <p:nvPr/>
-      </p:nvGrpSpPr>
-      <p:grpSpPr>
-        <a:xfrm>
-          <a:off x="0" y="0"/>
-          <a:ext cx="0" cy="0"/>
-          <a:chOff x="0" y="0"/>
-          <a:chExt cx="0" cy="0"/>
-        </a:xfrm>
-      </p:grpSpPr>
-      <p:sp>
-        <p:nvSpPr>
-          <p:cNvPr id="2" name="Title 1"/>
-          <p:cNvSpPr>
-            <a:spLocks noGrp="1"/>
-          </p:cNvSpPr>
-          <p:nvPr>
-            <p:ph type="title"/>
-          </p:nvPr>
-        </p:nvSpPr>
-        <p:spPr/>
-        <p:txBody>
-          <a:bodyPr/>
-          <a:lstStyle/>
-          <a:p>
-            <a:pPr lvl="0" indent="0" marL="0">
-              <a:buNone/>
-            </a:pPr>
-            <a:r>
-              <a:rPr/>
-              <a:t>Next Steps</a:t>
-            </a:r>
-          </a:p>
-        </p:txBody>
-      </p:sp>
-      <p:sp>
-        <p:nvSpPr>
-          <p:cNvPr id="3" name="Content Placeholder 2"/>
-          <p:cNvSpPr>
-            <a:spLocks noGrp="1"/>
-          </p:cNvSpPr>
-          <p:nvPr>
-            <p:ph idx="1"/>
-          </p:nvPr>
-        </p:nvSpPr>
-        <p:spPr/>
-        <p:txBody>
-          <a:bodyPr/>
-          <a:lstStyle/>
-          <a:p>
-            <a:pPr lvl="0" indent="-342900" marL="342900">
-              <a:buAutoNum type="arabicPeriod"/>
-            </a:pPr>
-            <a:r>
-              <a:rPr/>
-              <a:t>Complete pilot testing across chat UX, editorial workflow, and promotion flows.</a:t>
-            </a:r>
-          </a:p>
-          <a:p>
-            <a:pPr lvl="0" indent="-342900" marL="342900">
-              <a:buAutoNum type="arabicPeriod"/>
-            </a:pPr>
-            <a:r>
-              <a:rPr/>
-              <a:t>Enable and evaluate grounded LLM mode against deterministic fallback behavior.</a:t>
-            </a:r>
-          </a:p>
-          <a:p>
-            <a:pPr lvl="0" indent="-342900" marL="342900">
-              <a:buAutoNum type="arabicPeriod"/>
-            </a:pPr>
-            <a:r>
-              <a:rPr/>
-              <a:t>Refine ingestion profiles for companion repositories and standards-specific scopes.</a:t>
-            </a:r>
-          </a:p>
-          <a:p>
-            <a:pPr lvl="0" indent="-342900" marL="342900">
-              <a:buAutoNum type="arabicPeriod"/>
-            </a:pPr>
-            <a:r>
-              <a:rPr/>
-              <a:t>Use pilot evidence to decide production hardening and deployment model.</a:t>
-            </a:r>
-          </a:p>
-        </p:txBody>
-      </p:sp>
-    </p:spTree>
-  </p:cSld>
-</p:sld>
-</file>
-
-<file path=ppt/slides/slide18.xml><?xml version="1.0" encoding="utf-8"?>
-<p:sld xmlns:a="http://schemas.openxmlformats.org/drawingml/2006/main" xmlns:r="http://schemas.openxmlformats.org/officeDocument/2006/relationships" xmlns:p="http://schemas.openxmlformats.org/presentationml/2006/main">
-  <p:cSld>
-    <p:spTree>
-      <p:nvGrpSpPr>
-        <p:cNvPr id="1" name=""/>
-        <p:cNvGrpSpPr/>
-        <p:nvPr/>
-      </p:nvGrpSpPr>
-      <p:grpSpPr>
-        <a:xfrm>
-          <a:off x="0" y="0"/>
-          <a:ext cx="0" cy="0"/>
-          <a:chOff x="0" y="0"/>
-          <a:chExt cx="0" cy="0"/>
-        </a:xfrm>
-      </p:grpSpPr>
-      <p:sp>
-        <p:nvSpPr>
-          <p:cNvPr id="2" name="Title 1"/>
-          <p:cNvSpPr>
-            <a:spLocks noGrp="1"/>
-          </p:cNvSpPr>
-          <p:nvPr>
-            <p:ph type="title"/>
-          </p:nvPr>
-        </p:nvSpPr>
-        <p:spPr/>
-        <p:txBody>
-          <a:bodyPr/>
-          <a:lstStyle/>
-          <a:p>
-            <a:pPr lvl="0" indent="0" marL="0">
-              <a:buNone/>
-            </a:pPr>
-            <a:r>
-              <a:rPr/>
-              <a:t>Appendix: Example Questions</a:t>
-            </a:r>
-          </a:p>
-        </p:txBody>
-      </p:sp>
-      <p:sp>
-        <p:nvSpPr>
-          <p:cNvPr id="3" name="Content Placeholder 2"/>
-          <p:cNvSpPr>
-            <a:spLocks noGrp="1"/>
-          </p:cNvSpPr>
-          <p:nvPr>
-            <p:ph idx="1"/>
-          </p:nvPr>
-        </p:nvSpPr>
-        <p:spPr/>
-        <p:txBody>
-          <a:bodyPr/>
-          <a:lstStyle/>
-          <a:p>
-            <a:pPr lvl="0"/>
-            <a:r>
-              <a:rPr/>
-              <a:t>How to use NeTEx for exchanging a timetable?</a:t>
-            </a:r>
-          </a:p>
-          <a:p>
-            <a:pPr lvl="0"/>
-            <a:r>
-              <a:rPr/>
-              <a:t>How to implement IDs for a Stop Place registry?</a:t>
-            </a:r>
-          </a:p>
-          <a:p>
-            <a:pPr lvl="0" indent="0" marL="0">
-              <a:buNone/>
-            </a:pPr>
-            <a:r>
-              <a:rPr/>
-              <a:t>Expected outputs: - practical implementation guidance, - explicit citations, - abstention where evidence is insufficient.</a:t>
-            </a:r>
-          </a:p>
-        </p:txBody>
-      </p:sp>
-    </p:spTree>
-  </p:cSld>
-</p:sld>
-</file>
-
-<file path=ppt/slides/slide19.xml><?xml version="1.0" encoding="utf-8"?>
-<p:sld xmlns:a="http://schemas.openxmlformats.org/drawingml/2006/main" xmlns:r="http://schemas.openxmlformats.org/officeDocument/2006/relationships" xmlns:p="http://schemas.openxmlformats.org/presentationml/2006/main">
-  <p:cSld>
-    <p:spTree>
-      <p:nvGrpSpPr>
-        <p:cNvPr id="1" name=""/>
-        <p:cNvGrpSpPr/>
-        <p:nvPr/>
-      </p:nvGrpSpPr>
-      <p:grpSpPr>
-        <a:xfrm>
-          <a:off x="0" y="0"/>
-          <a:ext cx="0" cy="0"/>
-          <a:chOff x="0" y="0"/>
-          <a:chExt cx="0" cy="0"/>
-        </a:xfrm>
-      </p:grpSpPr>
-      <p:sp>
-        <p:nvSpPr>
-          <p:cNvPr id="2" name="Title 1"/>
-          <p:cNvSpPr>
-            <a:spLocks noGrp="1"/>
-          </p:cNvSpPr>
-          <p:nvPr>
-            <p:ph type="title"/>
-          </p:nvPr>
-        </p:nvSpPr>
-        <p:spPr/>
-        <p:txBody>
-          <a:bodyPr/>
-          <a:lstStyle/>
-          <a:p>
-            <a:pPr lvl="0" indent="0" marL="0">
-              <a:buNone/>
-            </a:pPr>
-            <a:r>
-              <a:rPr/>
-              <a:t>Notes</a:t>
-            </a:r>
-          </a:p>
-        </p:txBody>
-      </p:sp>
-      <p:sp>
-        <p:nvSpPr>
-          <p:cNvPr id="3" name="Content Placeholder 2"/>
-          <p:cNvSpPr>
-            <a:spLocks noGrp="1"/>
-          </p:cNvSpPr>
-          <p:nvPr>
-            <p:ph idx="1"/>
-          </p:nvPr>
-        </p:nvSpPr>
-        <p:spPr/>
-        <p:txBody>
-          <a:bodyPr/>
-          <a:lstStyle/>
-          <a:p>
-            <a:pPr lvl="0" indent="0" marL="0">
-              <a:buNone/>
-            </a:pPr>
-            <a:r>
               <a:rPr sz="1800"/>
-              <a:t>1. In a helpdesk or FAQ system, a RAG fallback (Retrieval‑Augmented Generation) happens when the system cannot find a good direct match (e.g., exact FAQ answer). It then falls back to RAG: retrieves the most relevant documents from approved sources, and generates an answer grounded in that retrieved context. The generation method depends on the profile: (1) </a:t>
-            </a:r>
-            <a:r>
-              <a:rPr sz="1800" b="1"/>
-              <a:t>Deterministic mode</a:t>
-            </a:r>
-            <a:r>
-              <a:rPr sz="1800"/>
-              <a:t> (now): uses pattern-matched templates adapted to the question, with confidence based on retrieval scores. (2) </a:t>
-            </a:r>
-            <a:r>
-              <a:rPr sz="1800" b="1"/>
-              <a:t>LLM-ready mode</a:t>
-            </a:r>
-            <a:r>
-              <a:rPr sz="1800"/>
-              <a:t> (future): feeds retrieved chunks to an LLM for synthesis. Both approaches prevent hallucination by grounding answers in real retrieved text.</a:t>
+              <a:t>1. RAG fallback means that when no high-confidence FAQ answer is available, the system retrieves relevant source chunks from approved repositories and generates an answer grounded in that retrieved evidence. In deterministic mode this is template-driven and score-based; in LLM-ready mode retrieved chunks are synthesized by the LLM while remaining evidence-bound.</a:t>
             </a:r>
           </a:p>
         </p:txBody>
@@ -4329,7 +3777,7 @@
             </a:pPr>
             <a:r>
               <a:rPr/>
-              <a:t>System Context (C4 Level 1)</a:t>
+              <a:t>Stakeholders And System Context (C4 Level 1)</a:t>
             </a:r>
           </a:p>
         </p:txBody>
@@ -4361,35 +3809,35 @@
             <a:pPr lvl="0"/>
             <a:r>
               <a:rPr/>
-              <a:t>PTO (Public Transport Operator) — responsible for daily service delivery</a:t>
+              <a:t>PTO (Public Transport Operator) — responsible for daily service delivery.</a:t>
             </a:r>
           </a:p>
           <a:p>
             <a:pPr lvl="0"/>
             <a:r>
               <a:rPr/>
-              <a:t>PTA (Public Transport Authority) — sets policy and compliance standards</a:t>
+              <a:t>PTA (Public Transport Authority) — sets policy and compliance standards.</a:t>
             </a:r>
           </a:p>
           <a:p>
             <a:pPr lvl="0"/>
             <a:r>
               <a:rPr/>
-              <a:t>Developer — implements integrations and APIs</a:t>
+              <a:t>Developer — implements integrations and APIs.</a:t>
             </a:r>
           </a:p>
           <a:p>
             <a:pPr lvl="0"/>
             <a:r>
               <a:rPr/>
-              <a:t>ITS System Integrator — connects helpdesk to broader mobility ecosystem</a:t>
+              <a:t>ITS System Integrator — connects helpdesk to broader mobility ecosystem.</a:t>
             </a:r>
           </a:p>
           <a:p>
             <a:pPr lvl="0"/>
             <a:r>
               <a:rPr/>
-              <a:t>Ticketing Agent — manages passenger-facing systems</a:t>
+              <a:t>Ticketing Agent — manages passenger-facing systems.</a:t>
             </a:r>
           </a:p>
           <a:p>
@@ -4405,37 +3853,14 @@
             <a:pPr lvl="0"/>
             <a:r>
               <a:rPr/>
-              <a:t>Approved GitHub repositories (NeTEx-CEN/NeTEx) — knowledge source</a:t>
+              <a:t>Approved GitHub repositories (NeTEx-CEN/NeTEx) — knowledge source.</a:t>
             </a:r>
           </a:p>
           <a:p>
             <a:pPr lvl="0"/>
             <a:r>
               <a:rPr/>
-              <a:t>LLM provider — grounded generation only; no unconstrained model memory</a:t>
-            </a:r>
-          </a:p>
-          <a:p>
-            <a:pPr lvl="0" indent="0" marL="0">
-              <a:buNone/>
-            </a:pPr>
-            <a:r>
-              <a:rPr b="1"/>
-              <a:t>Key architectural constraint:</a:t>
-            </a:r>
-          </a:p>
-          <a:p>
-            <a:pPr lvl="0"/>
-            <a:r>
-              <a:rPr/>
-              <a:t>All answers sourced from approved repositories only.</a:t>
-            </a:r>
-          </a:p>
-          <a:p>
-            <a:pPr lvl="0"/>
-            <a:r>
-              <a:rPr/>
-              <a:t>If evidence is insufficient, the system abstains rather than speculating.</a:t>
+              <a:t>LLM provider — optional grounded generation path.</a:t>
             </a:r>
           </a:p>
         </p:txBody>
@@ -4456,8 +3881,8 @@
         </p:blipFill>
         <p:spPr bwMode="auto">
           <a:xfrm>
-            <a:off x="4127500" y="203200"/>
-            <a:ext cx="3987800" cy="3873500"/>
+            <a:off x="3860800" y="203200"/>
+            <a:ext cx="4508500" cy="4381500"/>
           </a:xfrm>
           <a:prstGeom prst="rect">
             <a:avLst/>
@@ -4470,38 +3895,6 @@
           </a:ln>
         </p:spPr>
       </p:pic>
-      <p:sp>
-        <p:nvSpPr>
-          <p:cNvPr id="1" name="TextBox 3"/>
-          <p:cNvSpPr txBox="1"/>
-          <p:nvPr>
-            <p:ph idx="1"/>
-          </p:nvPr>
-        </p:nvSpPr>
-        <p:spPr>
-          <a:xfrm>
-            <a:off x="3568700" y="4076700"/>
-            <a:ext cx="5105400" cy="508000"/>
-          </a:xfrm>
-          <a:prstGeom prst="rect">
-            <a:avLst/>
-          </a:prstGeom>
-          <a:noFill/>
-        </p:spPr>
-        <p:txBody>
-          <a:bodyPr/>
-          <a:lstStyle/>
-          <a:p>
-            <a:pPr lvl="0" indent="0" marL="0" algn="ctr">
-              <a:buNone/>
-            </a:pPr>
-            <a:r>
-              <a:rPr/>
-              <a:t>C4 System Context Diagram</a:t>
-            </a:r>
-          </a:p>
-        </p:txBody>
-      </p:sp>
     </p:spTree>
   </p:cSld>
 </p:sld>
@@ -4544,7 +3937,7 @@
             </a:pPr>
             <a:r>
               <a:rPr/>
-              <a:t>Scope</a:t>
+              <a:t>Documentation Scope</a:t>
             </a:r>
           </a:p>
         </p:txBody>
@@ -4581,7 +3974,7 @@
             <a:pPr lvl="0"/>
             <a:r>
               <a:rPr/>
-              <a:t>Demo surfaces are now split into </a:t>
+              <a:t>Surfaces: separate user route (</a:t>
             </a:r>
             <a:r>
               <a:rPr>
@@ -4591,7 +3984,7 @@
             </a:r>
             <a:r>
               <a:rPr/>
-              <a:t> and </a:t>
+              <a:t>) and operator route (</a:t>
             </a:r>
             <a:r>
               <a:rPr>
@@ -4601,7 +3994,7 @@
             </a:r>
             <a:r>
               <a:rPr/>
-              <a:t> routes over one shared backend/session shell.</a:t>
+              <a:t>) over one shared backend shell.</a:t>
             </a:r>
           </a:p>
         </p:txBody>
@@ -4648,7 +4041,7 @@
             </a:pPr>
             <a:r>
               <a:rPr/>
-              <a:t>Evolution Of Helpdesk Implementations</a:t>
+              <a:t>Core Approach</a:t>
             </a:r>
           </a:p>
         </p:txBody>
@@ -4671,35 +4064,67 @@
             <a:pPr lvl="0"/>
             <a:r>
               <a:rPr/>
-              <a:t>Stage 1: keyword search over standards documents.</a:t>
+              <a:t>FAQ-first with RAG fallback.</a:t>
+            </a:r>
+            <a:r>
+              <a:rPr baseline="30000">
+                <a:hlinkClick r:id="rId2" action="ppaction://hlinksldjump"/>
+              </a:rPr>
+              <a:t>1</a:t>
             </a:r>
           </a:p>
           <a:p>
             <a:pPr lvl="0"/>
             <a:r>
               <a:rPr/>
-              <a:t>Stage 2: grounded Q and A with FAQ-first orchestration.</a:t>
+              <a:t>FAQ-first: return approved answers when confidence is high.</a:t>
             </a:r>
           </a:p>
           <a:p>
             <a:pPr lvl="0"/>
             <a:r>
               <a:rPr/>
-              <a:t>Stage 3: editorial workflow, routing, and KPI visibility.</a:t>
+              <a:t>RAG fallback: retrieve source chunks, then generate a grounded answer.</a:t>
             </a:r>
           </a:p>
           <a:p>
             <a:pPr lvl="0"/>
             <a:r>
               <a:rPr/>
-              <a:t>Stage 4: chat-style sessions ready for deterministic and LLM-backed generation.</a:t>
+              <a:t>Generation profiles:</a:t>
+            </a:r>
+          </a:p>
+          <a:p>
+            <a:pPr lvl="1"/>
+            <a:r>
+              <a:rPr>
+                <a:latin typeface="Courier"/>
+              </a:rPr>
+              <a:t>deterministic-grounded</a:t>
+            </a:r>
+            <a:r>
+              <a:rPr/>
+              <a:t> (active): question-adaptive deterministic templates with retrieval-score confidence.</a:t>
+            </a:r>
+          </a:p>
+          <a:p>
+            <a:pPr lvl="1"/>
+            <a:r>
+              <a:rPr>
+                <a:latin typeface="Courier"/>
+              </a:rPr>
+              <a:t>llm-ready</a:t>
+            </a:r>
+            <a:r>
+              <a:rPr/>
+              <a:t> (optional): retrieved chunks passed to LLM synthesis when enabled.</a:t>
             </a:r>
           </a:p>
           <a:p>
             <a:pPr lvl="0"/>
             <a:r>
               <a:rPr/>
-              <a:t>The trust model stays fixed: allow-listed repositories, citations, and review gates.</a:t>
+              <a:t>If evidence is weak, abstain explicitly.</a:t>
             </a:r>
           </a:p>
         </p:txBody>
@@ -4746,7 +4171,7 @@
             </a:pPr>
             <a:r>
               <a:rPr/>
-              <a:t>Why The Evolution Matters</a:t>
+              <a:t>Functional Requirements Highlights</a:t>
             </a:r>
           </a:p>
         </p:txBody>
@@ -4769,35 +4194,35 @@
             <a:pPr lvl="0"/>
             <a:r>
               <a:rPr/>
-              <a:t>Search helps lookup, but not decision-ready guidance.</a:t>
+              <a:t>FR-001: question answering through the helpdesk UI.</a:t>
             </a:r>
           </a:p>
           <a:p>
             <a:pPr lvl="0"/>
             <a:r>
               <a:rPr/>
-              <a:t>FAQ-first gives low-latency canonical answers for recurring issues.</a:t>
+              <a:t>FR-004: ingestion and indexing of approved GitHub sources.</a:t>
             </a:r>
           </a:p>
           <a:p>
             <a:pPr lvl="0"/>
             <a:r>
               <a:rPr/>
-              <a:t>Editorial workflow converts runtime demand into governed knowledge.</a:t>
+              <a:t>FR-005: retrieval and grounded generation.</a:t>
             </a:r>
           </a:p>
           <a:p>
             <a:pPr lvl="0"/>
             <a:r>
               <a:rPr/>
-              <a:t>Chat sessions improve usability without weakening provenance.</a:t>
+              <a:t>FR-006: anti-hallucination and boundary enforcement.</a:t>
             </a:r>
           </a:p>
           <a:p>
             <a:pPr lvl="0"/>
             <a:r>
               <a:rPr/>
-              <a:t>Companion repositories expand coverage without relaxing the trust boundary.</a:t>
+              <a:t>FR-002 and FR-003: editorial curation and FAQ promotion.</a:t>
             </a:r>
           </a:p>
         </p:txBody>
@@ -4844,7 +4269,7 @@
             </a:pPr>
             <a:r>
               <a:rPr/>
-              <a:t>Core Approach</a:t>
+              <a:t>Current Product State</a:t>
             </a:r>
           </a:p>
         </p:txBody>
@@ -4867,41 +4292,28 @@
             <a:pPr lvl="0"/>
             <a:r>
               <a:rPr/>
-              <a:t>FAQ-first with RAG fallback.</a:t>
-            </a:r>
-            <a:r>
-              <a:rPr baseline="30000">
-                <a:hlinkClick r:id="rId2" action="ppaction://hlinksldjump"/>
-              </a:rPr>
-              <a:t>1</a:t>
+              <a:t>Frontend now exposes separate routed surfaces for user chat and operator console.</a:t>
             </a:r>
           </a:p>
           <a:p>
             <a:pPr lvl="0"/>
             <a:r>
               <a:rPr/>
-              <a:t>FAQ-first: return approved answers when confidence is high.</a:t>
+              <a:t>Backend supports deterministic grounded generation and an optional LLM-ready mode.</a:t>
             </a:r>
           </a:p>
           <a:p>
             <a:pPr lvl="0"/>
             <a:r>
               <a:rPr/>
-              <a:t>RAG fallback: retrieve source chunks, then generate a grounded answer (deterministic templates now, LLM synthesis when enabled).</a:t>
+              <a:t>Knowledge index is built from approved repositories and selected companion repositories.</a:t>
             </a:r>
           </a:p>
           <a:p>
             <a:pPr lvl="0"/>
             <a:r>
               <a:rPr/>
-              <a:t>Generation profiles: deterministic-grounded now, LLM-ready when configured.</a:t>
-            </a:r>
-          </a:p>
-          <a:p>
-            <a:pPr lvl="0"/>
-            <a:r>
-              <a:rPr/>
-              <a:t>If evidence is weak, abstain explicitly.</a:t>
+              <a:t>Shared connection state keeps auth and backend targeting consistent across both routes.</a:t>
             </a:r>
           </a:p>
         </p:txBody>
@@ -4938,7 +4350,12 @@
             <p:ph type="title"/>
           </p:nvPr>
         </p:nvSpPr>
-        <p:spPr/>
+        <p:spPr>
+          <a:xfrm>
+            <a:off x="457201" y="204787"/>
+            <a:ext cx="3008313" cy="871538"/>
+          </a:xfrm>
+        </p:spPr>
         <p:txBody>
           <a:bodyPr/>
           <a:lstStyle/>
@@ -4948,19 +4365,19 @@
             </a:pPr>
             <a:r>
               <a:rPr/>
-              <a:t>Trust And Safety</a:t>
-            </a:r>
-          </a:p>
-        </p:txBody>
-      </p:sp>
-      <p:sp>
-        <p:nvSpPr>
-          <p:cNvPr id="3" name="Content Placeholder 2"/>
-          <p:cNvSpPr>
-            <a:spLocks noGrp="1"/>
-          </p:cNvSpPr>
-          <p:nvPr>
-            <p:ph idx="1"/>
+              <a:t>Current Chat UX</a:t>
+            </a:r>
+          </a:p>
+        </p:txBody>
+      </p:sp>
+      <p:sp>
+        <p:nvSpPr>
+          <p:cNvPr id="4" name="Text Placeholder 3"/>
+          <p:cNvSpPr>
+            <a:spLocks noGrp="1"/>
+          </p:cNvSpPr>
+          <p:nvPr>
+            <p:ph idx="2" sz="half" type="body"/>
           </p:nvPr>
         </p:nvSpPr>
         <p:spPr/>
@@ -4971,32 +4388,48 @@
             <a:pPr lvl="0"/>
             <a:r>
               <a:rPr/>
-              <a:t>Repository allowlist enforces the knowledge boundary.</a:t>
+              <a:t>User route and operator route are shown in full-size screenshots.</a:t>
             </a:r>
           </a:p>
           <a:p>
             <a:pPr lvl="0"/>
             <a:r>
               <a:rPr/>
-              <a:t>Generation is limited to retrieved evidence.</a:t>
-            </a:r>
-          </a:p>
-          <a:p>
-            <a:pPr lvl="0"/>
-            <a:r>
-              <a:rPr/>
-              <a:t>Citation gate blocks uncited publication.</a:t>
-            </a:r>
-          </a:p>
-          <a:p>
-            <a:pPr lvl="0"/>
-            <a:r>
-              <a:rPr/>
-              <a:t>Editorial gate controls draft, review, approve, and publish states.</a:t>
-            </a:r>
-          </a:p>
-        </p:txBody>
-      </p:sp>
+              <a:t>Connection fields are intentionally blank for presentation clarity.</a:t>
+            </a:r>
+          </a:p>
+        </p:txBody>
+      </p:sp>
+      <p:pic>
+        <p:nvPicPr>
+          <p:cNvPr descr="docs/presentation/assets/user-chat-empty-full.png" id="0" name="Picture 1"/>
+          <p:cNvPicPr>
+            <a:picLocks noGrp="1" noChangeAspect="1"/>
+          </p:cNvPicPr>
+          <p:nvPr/>
+        </p:nvPicPr>
+        <p:blipFill>
+          <a:blip r:embed="rId2"/>
+          <a:stretch>
+            <a:fillRect/>
+          </a:stretch>
+        </p:blipFill>
+        <p:spPr bwMode="auto">
+          <a:xfrm>
+            <a:off x="3568700" y="952500"/>
+            <a:ext cx="5105400" cy="2870200"/>
+          </a:xfrm>
+          <a:prstGeom prst="rect">
+            <a:avLst/>
+          </a:prstGeom>
+          <a:noFill/>
+          <a:ln w="9525">
+            <a:noFill/>
+            <a:headEnd/>
+            <a:tailEnd/>
+          </a:ln>
+        </p:spPr>
+      </p:pic>
     </p:spTree>
   </p:cSld>
 </p:sld>
@@ -5019,82 +4452,36 @@
           <a:chExt cx="0" cy="0"/>
         </a:xfrm>
       </p:grpSpPr>
-      <p:sp>
-        <p:nvSpPr>
-          <p:cNvPr id="2" name="Title 1"/>
-          <p:cNvSpPr>
-            <a:spLocks noGrp="1"/>
-          </p:cNvSpPr>
-          <p:nvPr>
-            <p:ph type="title"/>
-          </p:nvPr>
-        </p:nvSpPr>
-        <p:spPr/>
-        <p:txBody>
-          <a:bodyPr/>
-          <a:lstStyle/>
-          <a:p>
-            <a:pPr lvl="0" indent="0" marL="0">
-              <a:buNone/>
-            </a:pPr>
-            <a:r>
-              <a:rPr/>
-              <a:t>Functional Requirements Highlights</a:t>
-            </a:r>
-          </a:p>
-        </p:txBody>
-      </p:sp>
-      <p:sp>
-        <p:nvSpPr>
-          <p:cNvPr id="3" name="Content Placeholder 2"/>
-          <p:cNvSpPr>
-            <a:spLocks noGrp="1"/>
-          </p:cNvSpPr>
-          <p:nvPr>
-            <p:ph idx="1"/>
-          </p:nvPr>
-        </p:nvSpPr>
-        <p:spPr/>
-        <p:txBody>
-          <a:bodyPr/>
-          <a:lstStyle/>
-          <a:p>
-            <a:pPr lvl="0"/>
-            <a:r>
-              <a:rPr/>
-              <a:t>FR-001: question answering through the helpdesk UI.</a:t>
-            </a:r>
-          </a:p>
-          <a:p>
-            <a:pPr lvl="0"/>
-            <a:r>
-              <a:rPr/>
-              <a:t>FR-004: ingestion and indexing of approved GitHub sources.</a:t>
-            </a:r>
-          </a:p>
-          <a:p>
-            <a:pPr lvl="0"/>
-            <a:r>
-              <a:rPr/>
-              <a:t>FR-005: retrieval and grounded generation.</a:t>
-            </a:r>
-          </a:p>
-          <a:p>
-            <a:pPr lvl="0"/>
-            <a:r>
-              <a:rPr/>
-              <a:t>FR-006: anti-hallucination and boundary enforcement.</a:t>
-            </a:r>
-          </a:p>
-          <a:p>
-            <a:pPr lvl="0"/>
-            <a:r>
-              <a:rPr/>
-              <a:t>FR-002 and FR-003: editorial curation and FAQ promotion.</a:t>
-            </a:r>
-          </a:p>
-        </p:txBody>
-      </p:sp>
+      <p:pic>
+        <p:nvPicPr>
+          <p:cNvPr descr="docs/presentation/assets/operator-console-empty-full.png" id="0" name="Picture 1"/>
+          <p:cNvPicPr>
+            <a:picLocks noGrp="1" noChangeAspect="1"/>
+          </p:cNvPicPr>
+          <p:nvPr/>
+        </p:nvPicPr>
+        <p:blipFill>
+          <a:blip r:embed="rId2"/>
+          <a:stretch>
+            <a:fillRect/>
+          </a:stretch>
+        </p:blipFill>
+        <p:spPr bwMode="auto">
+          <a:xfrm>
+            <a:off x="1562100" y="1193800"/>
+            <a:ext cx="6032500" cy="3390900"/>
+          </a:xfrm>
+          <a:prstGeom prst="rect">
+            <a:avLst/>
+          </a:prstGeom>
+          <a:noFill/>
+          <a:ln w="9525">
+            <a:noFill/>
+            <a:headEnd/>
+            <a:tailEnd/>
+          </a:ln>
+        </p:spPr>
+      </p:pic>
     </p:spTree>
   </p:cSld>
 </p:sld>

</xml_diff>